<commit_message>
Deck review fixes: real code slide, body text sizes, portable paths
Slide 9 now cites backend/predictor.py and shows the actual inference
path (predict_proba votes, isotonic calibration, 1.645-sigma band on
the calibrated score) instead of invented pseudo-code pointing at a
nonexistent file. Callout and caption text bumped to the 24 pt body
floor; build script resolves paths from __file__.

Generated with [Devin](https://devin.ai)

Co-Authored-By: Devin <158243242+devin-ai-integration[bot]@users.noreply.github.com>
</commit_message>
<xml_diff>
--- a/ResistanceAI_Presentation_v9.pptx
+++ b/ResistanceAI_Presentation_v9.pptx
@@ -1283,7 +1283,7 @@
           <a:lstStyle/>
           <a:p>
             <a:r>
-              <a:t>This is the honest part, in the actual code. The eight models vote, we take the mean, then we measure how much they disagree. Large disagreement becomes a wide band on screen. The app never pretends to be sure when it is not.</a:t>
+              <a:t>This is the honest part, in the actual code. The eight models vote, their average is calibrated into a probability, and how much they disagree sets the width of the band on screen. It is a disagreement measure, not a guarantee, and the app never pretends to be sure when it is not.</a:t>
             </a:r>
           </a:p>
         </p:txBody>
@@ -5039,7 +5039,7 @@
               </a:spcAft>
             </a:pPr>
             <a:r>
-              <a:rPr sz="2000" b="0">
+              <a:rPr sz="2400" b="0">
                 <a:solidFill>
                   <a:srgbClr val="94A3B8"/>
                 </a:solidFill>
@@ -5058,7 +5058,7 @@
               </a:spcAft>
             </a:pPr>
             <a:r>
-              <a:rPr sz="2000" b="0">
+              <a:rPr sz="2400" b="0">
                 <a:solidFill>
                   <a:srgbClr val="94A3B8"/>
                 </a:solidFill>
@@ -5077,7 +5077,7 @@
               </a:spcAft>
             </a:pPr>
             <a:r>
-              <a:rPr sz="2000" b="0">
+              <a:rPr sz="2400" b="0">
                 <a:solidFill>
                   <a:srgbClr val="94A3B8"/>
                 </a:solidFill>
@@ -5096,7 +5096,7 @@
               </a:spcAft>
             </a:pPr>
             <a:r>
-              <a:rPr sz="2000" b="0">
+              <a:rPr sz="2400" b="0">
                 <a:solidFill>
                   <a:srgbClr val="94A3B8"/>
                 </a:solidFill>
@@ -5115,7 +5115,7 @@
               </a:spcAft>
             </a:pPr>
             <a:r>
-              <a:rPr sz="2000" b="0">
+              <a:rPr sz="2400" b="0">
                 <a:solidFill>
                   <a:srgbClr val="94A3B8"/>
                 </a:solidFill>
@@ -5579,14 +5579,32 @@
               </a:spcAft>
             </a:pPr>
             <a:r>
-              <a:rPr sz="2000" b="0">
+              <a:rPr sz="2400" b="0">
                 <a:solidFill>
                   <a:srgbClr val="94A3B8"/>
                 </a:solidFill>
                 <a:latin typeface="Segoe UI"/>
               </a:rPr>
-              <a:t>The doctor who treats cancer.
-When the DNA report arrives, they choose the drug. The report is long, the evidence is scattered, and the clock is running.</a:t>
+              <a:t>The doctor who treats cancer.</a:t>
+            </a:r>
+          </a:p>
+          <a:p>
+            <a:pPr algn="l">
+              <a:lnSpc>
+                <a:spcPct val="120000"/>
+              </a:lnSpc>
+              <a:spcAft>
+                <a:spcPts val="800"/>
+              </a:spcAft>
+            </a:pPr>
+            <a:r>
+              <a:rPr sz="2400" b="0">
+                <a:solidFill>
+                  <a:srgbClr val="94A3B8"/>
+                </a:solidFill>
+                <a:latin typeface="Segoe UI"/>
+              </a:rPr>
+              <a:t>When the DNA report lands, they choose the drug, often alone.</a:t>
             </a:r>
           </a:p>
         </p:txBody>
@@ -5862,13 +5880,13 @@
               </a:spcAft>
             </a:pPr>
             <a:r>
-              <a:rPr sz="2000" b="0">
+              <a:rPr sz="2400" b="0">
                 <a:solidFill>
                   <a:srgbClr val="94A3B8"/>
                 </a:solidFill>
                 <a:latin typeface="Segoe UI"/>
               </a:rPr>
-              <a:t>Two public research datasets from Memorial Sloan Kettering, one of the largest cancer centers in the world.</a:t>
+              <a:t>Two public datasets from Memorial Sloan Kettering, one of the largest cancer centers in the world.</a:t>
             </a:r>
           </a:p>
         </p:txBody>
@@ -6275,8 +6293,8 @@
         </p:nvSpPr>
         <p:spPr>
           <a:xfrm>
-            <a:off x="777240" y="6400800"/>
-            <a:ext cx="10607040" cy="365760"/>
+            <a:off x="777240" y="6355080"/>
+            <a:ext cx="10607040" cy="411480"/>
           </a:xfrm>
           <a:prstGeom prst="rect">
             <a:avLst/>
@@ -6298,13 +6316,13 @@
               </a:spcAft>
             </a:pPr>
             <a:r>
-              <a:rPr sz="1800" b="0">
+              <a:rPr sz="2400" b="0">
                 <a:solidFill>
                   <a:srgbClr val="94A3B8"/>
                 </a:solidFill>
                 <a:latin typeface="Segoe UI"/>
               </a:rPr>
-              <a:t>Left: each feature's push on the score.   Right: escape routes to watch, each citing the mutation it found.</a:t>
+              <a:t>Left: what moved the score.   Right: the cited evidence.</a:t>
             </a:r>
           </a:p>
         </p:txBody>
@@ -6544,7 +6562,7 @@
               </a:spcAft>
             </a:pPr>
             <a:r>
-              <a:rPr sz="2000" b="0">
+              <a:rPr sz="2400" b="0">
                 <a:solidFill>
                   <a:srgbClr val="94A3B8"/>
                 </a:solidFill>
@@ -6742,13 +6760,13 @@
               </a:spcAft>
             </a:pPr>
             <a:r>
-              <a:rPr sz="2100" b="1">
+              <a:rPr sz="2400" b="1">
                 <a:solidFill>
                   <a:srgbClr val="F1F5F9"/>
                 </a:solidFill>
                 <a:latin typeface="Segoe UI"/>
               </a:rPr>
-              <a:t>DNA report in</a:t>
+              <a:t>DNA report</a:t>
             </a:r>
           </a:p>
         </p:txBody>
@@ -6956,7 +6974,7 @@
               </a:spcAft>
             </a:pPr>
             <a:r>
-              <a:rPr sz="2100" b="1">
+              <a:rPr sz="2400" b="1">
                 <a:solidFill>
                   <a:srgbClr val="F1F5F9"/>
                 </a:solidFill>
@@ -7170,7 +7188,7 @@
               </a:spcAft>
             </a:pPr>
             <a:r>
-              <a:rPr sz="2100" b="1">
+              <a:rPr sz="2400" b="1">
                 <a:solidFill>
                   <a:srgbClr val="F1F5F9"/>
                 </a:solidFill>
@@ -7384,13 +7402,13 @@
               </a:spcAft>
             </a:pPr>
             <a:r>
-              <a:rPr sz="2100" b="1">
+              <a:rPr sz="2400" b="1">
                 <a:solidFill>
                   <a:srgbClr val="F1F5F9"/>
                 </a:solidFill>
                 <a:latin typeface="Segoe UI"/>
               </a:rPr>
-              <a:t>A probability</a:t>
+              <a:t>Probability</a:t>
             </a:r>
           </a:p>
         </p:txBody>
@@ -7674,7 +7692,7 @@
                 </a:solidFill>
                 <a:latin typeface="Consolas"/>
               </a:rPr>
-              <a:t>votes   = [m.predict(X) for m in self.models]</a:t>
+              <a:t>votes = [m.predict_proba(x)[:, 1][0] for m in self.models]</a:t>
             </a:r>
           </a:p>
         </p:txBody>
@@ -7716,7 +7734,7 @@
                 </a:solidFill>
                 <a:latin typeface="Consolas"/>
               </a:rPr>
-              <a:t>mean    = float(np.mean(votes))        # the estimate</a:t>
+              <a:t>proba = self.isotonic.predict([np.mean(votes)])[0]</a:t>
             </a:r>
           </a:p>
         </p:txBody>
@@ -7758,7 +7776,7 @@
                 </a:solidFill>
                 <a:latin typeface="Consolas"/>
               </a:rPr>
-              <a:t>spread  = float(np.std(votes))         # the disagreement</a:t>
+              <a:t>score = int(round(proba * 100))    # the estimate</a:t>
             </a:r>
           </a:p>
         </p:txBody>
@@ -7842,7 +7860,7 @@
                 </a:solidFill>
                 <a:latin typeface="Consolas"/>
               </a:rPr>
-              <a:t>low, high = calibrate(mean - 2*spread,</a:t>
+              <a:t>half  = max(2, int(round(1.645 * np.std(votes) * 100)))</a:t>
             </a:r>
           </a:p>
         </p:txBody>
@@ -7884,7 +7902,7 @@
                 </a:solidFill>
                 <a:latin typeface="Consolas"/>
               </a:rPr>
-              <a:t>              mean + 2*spread)</a:t>
+              <a:t>ci    = [max(0, score - half), min(100, score + half)]</a:t>
             </a:r>
           </a:p>
         </p:txBody>
@@ -7926,7 +7944,7 @@
                 </a:solidFill>
                 <a:latin typeface="Consolas"/>
               </a:rPr>
-              <a:t>backend/ensemble.py</a:t>
+              <a:t>backend/predictor.py</a:t>
             </a:r>
           </a:p>
         </p:txBody>
@@ -7968,7 +7986,7 @@
                 </a:solidFill>
                 <a:latin typeface="Segoe UI"/>
               </a:rPr>
-              <a:t>Eight models vote, we take the average.</a:t>
+              <a:t>Eight models vote; their average becomes the score.</a:t>
             </a:r>
           </a:p>
           <a:p>
@@ -7987,7 +8005,7 @@
                 </a:solidFill>
                 <a:latin typeface="Segoe UI"/>
               </a:rPr>
-              <a:t>Their disagreement becomes the band.</a:t>
+              <a:t>Their disagreement sets the band's width.</a:t>
             </a:r>
           </a:p>
           <a:p>
@@ -8006,7 +8024,7 @@
                 </a:solidFill>
                 <a:latin typeface="Segoe UI"/>
               </a:rPr>
-              <a:t>Wide band means slow down and look closer.</a:t>
+              <a:t>A wide band means slow down and look closer.</a:t>
             </a:r>
           </a:p>
         </p:txBody>

</xml_diff>

<commit_message>
Rework slide 9 as a graphical data-flow diagram
Replaces the card-lane layout with real DFD glyphs: process circles,
CAN data-store cylinders, external-entity rectangles, connector
arrows with XML arrowheads, labeled flows, dashed load/fetch paths,
and a legend. Verified via PowerPoint render.

Generated with [Devin](https://devin.ai)

Co-Authored-By: Devin <158243242+devin-ai-integration[bot]@users.noreply.github.com>
</commit_message>
<xml_diff>
--- a/ResistanceAI_Presentation_v9.pptx
+++ b/ResistanceAI_Presentation_v9.pptx
@@ -1425,7 +1425,7 @@
           <a:lstStyle/>
           <a:p>
             <a:r>
-              <a:t>Here is the whole system on one slide. The top lane runs once: the two Memorial Sloan Kettering datasets are pulled through cBioPortal, cleaned into the 201-signal schema, stored as the 26,064-patient corpus, then eight models are trained and calibrated. The corpus and model artifact load once when the app starts. The bottom lane is what happens for every patient: a report is normalized into the same 201 signals, the predictor returns the score, the honest band and the why, then the engines find similar patients and safe cohort stats, all of which the Streamlit UI, or the Flask API for other software, displays. Two outside services join live: ClinicalTrials.gov for recruiting trials and cBioPortal for the source data.</a:t>
+              <a:t>Read it like a data-flow diagram. Circles are things the code does, cylinders are stored data, rectangles are the outside world, and every arrow is labeled with what moves along it. Top lane, run once: data leaves cBioPortal, ingest cleans it into the 201-signal schema, the corpus stores 26,064 records, training writes one calibrated artifact. Bottom lane, every request: a genomic report is normalized, Predict turns it into a score, Match finds similar patients and safe cohorts, and the result reaches the oncologist through Streamlit or the Flask API. The two dashed lines are the only crossings: the artifact loads into Predict and the corpus loads into Match at startup. ClinicalTrials.gov is the one live fetch — trials are searched fresh for each patient.</a:t>
             </a:r>
           </a:p>
         </p:txBody>
@@ -13198,7 +13198,7 @@
                 </a:solidFill>
                 <a:latin typeface="Georgia"/>
               </a:rPr>
-              <a:t>Two pipelines: one built the brain, one runs it.</a:t>
+              <a:t>Trace the data: trained once, then scored per request.</a:t>
             </a:r>
           </a:p>
         </p:txBody>
@@ -13284,26 +13284,24 @@
                 </a:solidFill>
                 <a:latin typeface="Consolas"/>
               </a:rPr>
-              <a:t>BUILT ONCE — TRAINING</a:t>
-            </a:r>
-          </a:p>
-        </p:txBody>
-      </p:sp>
-      <p:sp>
-        <p:nvSpPr>
-          <p:cNvPr id="7" name="Rounded Rectangle 6"/>
+              <a:t>OFFLINE — TRAINS ONCE</a:t>
+            </a:r>
+          </a:p>
+        </p:txBody>
+      </p:sp>
+      <p:sp>
+        <p:nvSpPr>
+          <p:cNvPr id="7" name="Rectangle 6"/>
           <p:cNvSpPr/>
           <p:nvPr/>
         </p:nvSpPr>
         <p:spPr>
           <a:xfrm>
-            <a:off x="777240" y="2359152"/>
-            <a:ext cx="1901952" cy="896112"/>
-          </a:xfrm>
-          <a:prstGeom prst="roundRect">
-            <a:avLst>
-              <a:gd name="adj" fmla="val 5000"/>
-            </a:avLst>
+            <a:off x="777240" y="2487168"/>
+            <a:ext cx="1371600" cy="777240"/>
+          </a:xfrm>
+          <a:prstGeom prst="rect">
+            <a:avLst/>
           </a:prstGeom>
           <a:solidFill>
             <a:srgbClr val="13202B"/>
@@ -13343,8 +13341,8 @@
         </p:nvSpPr>
         <p:spPr>
           <a:xfrm>
-            <a:off x="905256" y="2478024"/>
-            <a:ext cx="1691640" cy="347472"/>
+            <a:off x="850392" y="2615184"/>
+            <a:ext cx="1225296" cy="320040"/>
           </a:xfrm>
           <a:prstGeom prst="rect">
             <a:avLst/>
@@ -13357,22 +13355,22 @@
           </a:bodyPr>
           <a:lstStyle/>
           <a:p>
-            <a:pPr algn="l">
-              <a:lnSpc>
-                <a:spcPct val="108000"/>
-              </a:lnSpc>
-              <a:spcAft>
-                <a:spcPts val="800"/>
-              </a:spcAft>
-            </a:pPr>
-            <a:r>
-              <a:rPr sz="1500" b="1">
+            <a:pPr algn="ctr">
+              <a:lnSpc>
+                <a:spcPct val="108000"/>
+              </a:lnSpc>
+              <a:spcAft>
+                <a:spcPts val="0"/>
+              </a:spcAft>
+            </a:pPr>
+            <a:r>
+              <a:rPr sz="1150" b="1">
                 <a:solidFill>
                   <a:srgbClr val="F2F7F6"/>
                 </a:solidFill>
-                <a:latin typeface="Consolas"/>
-              </a:rPr>
-              <a:t>MSK datasets</a:t>
+                <a:latin typeface="Georgia"/>
+              </a:rPr>
+              <a:t>cBioPortal</a:t>
             </a:r>
           </a:p>
         </p:txBody>
@@ -13385,8 +13383,8 @@
         </p:nvSpPr>
         <p:spPr>
           <a:xfrm>
-            <a:off x="905256" y="2852928"/>
-            <a:ext cx="1691640" cy="347472"/>
+            <a:off x="850392" y="2944368"/>
+            <a:ext cx="1225296" cy="256032"/>
           </a:xfrm>
           <a:prstGeom prst="rect">
             <a:avLst/>
@@ -13399,16 +13397,16 @@
           </a:bodyPr>
           <a:lstStyle/>
           <a:p>
-            <a:pPr algn="l">
-              <a:lnSpc>
-                <a:spcPct val="108000"/>
-              </a:lnSpc>
-              <a:spcAft>
-                <a:spcPts val="800"/>
-              </a:spcAft>
-            </a:pPr>
-            <a:r>
-              <a:rPr sz="1100" b="0">
+            <a:pPr algn="ctr">
+              <a:lnSpc>
+                <a:spcPct val="108000"/>
+              </a:lnSpc>
+              <a:spcAft>
+                <a:spcPts val="0"/>
+              </a:spcAft>
+            </a:pPr>
+            <a:r>
+              <a:rPr sz="900" b="0">
                 <a:solidFill>
                   <a:srgbClr val="8CA3AD"/>
                 </a:solidFill>
@@ -13421,19 +13419,537 @@
       </p:sp>
       <p:sp>
         <p:nvSpPr>
-          <p:cNvPr id="10" name="Rounded Rectangle 9"/>
+          <p:cNvPr id="10" name="Oval 9"/>
           <p:cNvSpPr/>
           <p:nvPr/>
         </p:nvSpPr>
         <p:spPr>
           <a:xfrm>
-            <a:off x="2971800" y="2359152"/>
-            <a:ext cx="1901952" cy="896112"/>
-          </a:xfrm>
-          <a:prstGeom prst="roundRect">
-            <a:avLst>
-              <a:gd name="adj" fmla="val 5000"/>
-            </a:avLst>
+            <a:off x="2743200" y="2331720"/>
+            <a:ext cx="1097280" cy="1097280"/>
+          </a:xfrm>
+          <a:prstGeom prst="ellipse">
+            <a:avLst/>
+          </a:prstGeom>
+          <a:solidFill>
+            <a:srgbClr val="14B8A6"/>
+          </a:solidFill>
+          <a:ln>
+            <a:solidFill>
+              <a:srgbClr val="14B8A6"/>
+            </a:solidFill>
+          </a:ln>
+          <a:effectLst/>
+        </p:spPr>
+        <p:style>
+          <a:lnRef idx="1">
+            <a:schemeClr val="accent1"/>
+          </a:lnRef>
+          <a:fillRef idx="3">
+            <a:schemeClr val="accent1"/>
+          </a:fillRef>
+          <a:effectRef idx="2">
+            <a:schemeClr val="accent1"/>
+          </a:effectRef>
+          <a:fontRef idx="minor">
+            <a:schemeClr val="lt1"/>
+          </a:fontRef>
+        </p:style>
+        <p:txBody>
+          <a:bodyPr rtlCol="0" anchor="ctr"/>
+          <a:lstStyle/>
+          <a:p>
+            <a:pPr algn="ctr"/>
+          </a:p>
+        </p:txBody>
+      </p:sp>
+      <p:sp>
+        <p:nvSpPr>
+          <p:cNvPr id="11" name="TextBox 10"/>
+          <p:cNvSpPr txBox="1"/>
+          <p:nvPr/>
+        </p:nvSpPr>
+        <p:spPr>
+          <a:xfrm>
+            <a:off x="2743200" y="2606040"/>
+            <a:ext cx="1097280" cy="292608"/>
+          </a:xfrm>
+          <a:prstGeom prst="rect">
+            <a:avLst/>
+          </a:prstGeom>
+          <a:noFill/>
+        </p:spPr>
+        <p:txBody>
+          <a:bodyPr wrap="square" anchor="t" lIns="0" rIns="0" tIns="0" bIns="0">
+            <a:spAutoFit/>
+          </a:bodyPr>
+          <a:lstStyle/>
+          <a:p>
+            <a:pPr algn="ctr">
+              <a:lnSpc>
+                <a:spcPct val="108000"/>
+              </a:lnSpc>
+              <a:spcAft>
+                <a:spcPts val="0"/>
+              </a:spcAft>
+            </a:pPr>
+            <a:r>
+              <a:rPr sz="1200" b="1">
+                <a:solidFill>
+                  <a:srgbClr val="062B27"/>
+                </a:solidFill>
+                <a:latin typeface="Georgia"/>
+              </a:rPr>
+              <a:t>Ingest</a:t>
+            </a:r>
+          </a:p>
+        </p:txBody>
+      </p:sp>
+      <p:sp>
+        <p:nvSpPr>
+          <p:cNvPr id="12" name="TextBox 11"/>
+          <p:cNvSpPr txBox="1"/>
+          <p:nvPr/>
+        </p:nvSpPr>
+        <p:spPr>
+          <a:xfrm>
+            <a:off x="2743200" y="2926079"/>
+            <a:ext cx="1097280" cy="237744"/>
+          </a:xfrm>
+          <a:prstGeom prst="rect">
+            <a:avLst/>
+          </a:prstGeom>
+          <a:noFill/>
+        </p:spPr>
+        <p:txBody>
+          <a:bodyPr wrap="square" anchor="t" lIns="0" rIns="0" tIns="0" bIns="0">
+            <a:spAutoFit/>
+          </a:bodyPr>
+          <a:lstStyle/>
+          <a:p>
+            <a:pPr algn="ctr">
+              <a:lnSpc>
+                <a:spcPct val="108000"/>
+              </a:lnSpc>
+              <a:spcAft>
+                <a:spcPts val="0"/>
+              </a:spcAft>
+            </a:pPr>
+            <a:r>
+              <a:rPr sz="800" b="0">
+                <a:solidFill>
+                  <a:srgbClr val="062B27"/>
+                </a:solidFill>
+                <a:latin typeface="Consolas"/>
+              </a:rPr>
+              <a:t>ingest_v2.py</a:t>
+            </a:r>
+          </a:p>
+        </p:txBody>
+      </p:sp>
+      <p:sp>
+        <p:nvSpPr>
+          <p:cNvPr id="13" name="Can 12"/>
+          <p:cNvSpPr/>
+          <p:nvPr/>
+        </p:nvSpPr>
+        <p:spPr>
+          <a:xfrm>
+            <a:off x="4434840" y="2468880"/>
+            <a:ext cx="1280160" cy="822960"/>
+          </a:xfrm>
+          <a:prstGeom prst="can">
+            <a:avLst/>
+          </a:prstGeom>
+          <a:solidFill>
+            <a:srgbClr val="13202B"/>
+          </a:solidFill>
+          <a:ln w="15875">
+            <a:solidFill>
+              <a:srgbClr val="14B8A6"/>
+            </a:solidFill>
+          </a:ln>
+          <a:effectLst/>
+        </p:spPr>
+        <p:style>
+          <a:lnRef idx="1">
+            <a:schemeClr val="accent1"/>
+          </a:lnRef>
+          <a:fillRef idx="3">
+            <a:schemeClr val="accent1"/>
+          </a:fillRef>
+          <a:effectRef idx="2">
+            <a:schemeClr val="accent1"/>
+          </a:effectRef>
+          <a:fontRef idx="minor">
+            <a:schemeClr val="lt1"/>
+          </a:fontRef>
+        </p:style>
+        <p:txBody>
+          <a:bodyPr rtlCol="0" anchor="ctr"/>
+          <a:lstStyle/>
+          <a:p>
+            <a:pPr algn="ctr"/>
+          </a:p>
+        </p:txBody>
+      </p:sp>
+      <p:sp>
+        <p:nvSpPr>
+          <p:cNvPr id="14" name="TextBox 13"/>
+          <p:cNvSpPr txBox="1"/>
+          <p:nvPr/>
+        </p:nvSpPr>
+        <p:spPr>
+          <a:xfrm>
+            <a:off x="4434840" y="2748686"/>
+            <a:ext cx="1280160" cy="274320"/>
+          </a:xfrm>
+          <a:prstGeom prst="rect">
+            <a:avLst/>
+          </a:prstGeom>
+          <a:noFill/>
+        </p:spPr>
+        <p:txBody>
+          <a:bodyPr wrap="square" anchor="t" lIns="0" rIns="0" tIns="0" bIns="0">
+            <a:spAutoFit/>
+          </a:bodyPr>
+          <a:lstStyle/>
+          <a:p>
+            <a:pPr algn="ctr">
+              <a:lnSpc>
+                <a:spcPct val="108000"/>
+              </a:lnSpc>
+              <a:spcAft>
+                <a:spcPts val="0"/>
+              </a:spcAft>
+            </a:pPr>
+            <a:r>
+              <a:rPr sz="1200" b="1">
+                <a:solidFill>
+                  <a:srgbClr val="F2F7F6"/>
+                </a:solidFill>
+                <a:latin typeface="Georgia"/>
+              </a:rPr>
+              <a:t>Corpus</a:t>
+            </a:r>
+          </a:p>
+        </p:txBody>
+      </p:sp>
+      <p:sp>
+        <p:nvSpPr>
+          <p:cNvPr id="15" name="TextBox 14"/>
+          <p:cNvSpPr txBox="1"/>
+          <p:nvPr/>
+        </p:nvSpPr>
+        <p:spPr>
+          <a:xfrm>
+            <a:off x="4434840" y="2979115"/>
+            <a:ext cx="1280160" cy="237744"/>
+          </a:xfrm>
+          <a:prstGeom prst="rect">
+            <a:avLst/>
+          </a:prstGeom>
+          <a:noFill/>
+        </p:spPr>
+        <p:txBody>
+          <a:bodyPr wrap="square" anchor="t" lIns="0" rIns="0" tIns="0" bIns="0">
+            <a:spAutoFit/>
+          </a:bodyPr>
+          <a:lstStyle/>
+          <a:p>
+            <a:pPr algn="ctr">
+              <a:lnSpc>
+                <a:spcPct val="108000"/>
+              </a:lnSpc>
+              <a:spcAft>
+                <a:spcPts val="0"/>
+              </a:spcAft>
+            </a:pPr>
+            <a:r>
+              <a:rPr sz="800" b="0">
+                <a:solidFill>
+                  <a:srgbClr val="8CA3AD"/>
+                </a:solidFill>
+                <a:latin typeface="Consolas"/>
+              </a:rPr>
+              <a:t>26,064 records</a:t>
+            </a:r>
+          </a:p>
+        </p:txBody>
+      </p:sp>
+      <p:sp>
+        <p:nvSpPr>
+          <p:cNvPr id="16" name="Oval 15"/>
+          <p:cNvSpPr/>
+          <p:nvPr/>
+        </p:nvSpPr>
+        <p:spPr>
+          <a:xfrm>
+            <a:off x="6309360" y="2331720"/>
+            <a:ext cx="1097280" cy="1097280"/>
+          </a:xfrm>
+          <a:prstGeom prst="ellipse">
+            <a:avLst/>
+          </a:prstGeom>
+          <a:solidFill>
+            <a:srgbClr val="14B8A6"/>
+          </a:solidFill>
+          <a:ln>
+            <a:solidFill>
+              <a:srgbClr val="14B8A6"/>
+            </a:solidFill>
+          </a:ln>
+          <a:effectLst/>
+        </p:spPr>
+        <p:style>
+          <a:lnRef idx="1">
+            <a:schemeClr val="accent1"/>
+          </a:lnRef>
+          <a:fillRef idx="3">
+            <a:schemeClr val="accent1"/>
+          </a:fillRef>
+          <a:effectRef idx="2">
+            <a:schemeClr val="accent1"/>
+          </a:effectRef>
+          <a:fontRef idx="minor">
+            <a:schemeClr val="lt1"/>
+          </a:fontRef>
+        </p:style>
+        <p:txBody>
+          <a:bodyPr rtlCol="0" anchor="ctr"/>
+          <a:lstStyle/>
+          <a:p>
+            <a:pPr algn="ctr"/>
+          </a:p>
+        </p:txBody>
+      </p:sp>
+      <p:sp>
+        <p:nvSpPr>
+          <p:cNvPr id="17" name="TextBox 16"/>
+          <p:cNvSpPr txBox="1"/>
+          <p:nvPr/>
+        </p:nvSpPr>
+        <p:spPr>
+          <a:xfrm>
+            <a:off x="6309360" y="2606040"/>
+            <a:ext cx="1097280" cy="292608"/>
+          </a:xfrm>
+          <a:prstGeom prst="rect">
+            <a:avLst/>
+          </a:prstGeom>
+          <a:noFill/>
+        </p:spPr>
+        <p:txBody>
+          <a:bodyPr wrap="square" anchor="t" lIns="0" rIns="0" tIns="0" bIns="0">
+            <a:spAutoFit/>
+          </a:bodyPr>
+          <a:lstStyle/>
+          <a:p>
+            <a:pPr algn="ctr">
+              <a:lnSpc>
+                <a:spcPct val="108000"/>
+              </a:lnSpc>
+              <a:spcAft>
+                <a:spcPts val="0"/>
+              </a:spcAft>
+            </a:pPr>
+            <a:r>
+              <a:rPr sz="1200" b="1">
+                <a:solidFill>
+                  <a:srgbClr val="062B27"/>
+                </a:solidFill>
+                <a:latin typeface="Georgia"/>
+              </a:rPr>
+              <a:t>Train</a:t>
+            </a:r>
+          </a:p>
+        </p:txBody>
+      </p:sp>
+      <p:sp>
+        <p:nvSpPr>
+          <p:cNvPr id="18" name="TextBox 17"/>
+          <p:cNvSpPr txBox="1"/>
+          <p:nvPr/>
+        </p:nvSpPr>
+        <p:spPr>
+          <a:xfrm>
+            <a:off x="6309360" y="2926079"/>
+            <a:ext cx="1097280" cy="237744"/>
+          </a:xfrm>
+          <a:prstGeom prst="rect">
+            <a:avLst/>
+          </a:prstGeom>
+          <a:noFill/>
+        </p:spPr>
+        <p:txBody>
+          <a:bodyPr wrap="square" anchor="t" lIns="0" rIns="0" tIns="0" bIns="0">
+            <a:spAutoFit/>
+          </a:bodyPr>
+          <a:lstStyle/>
+          <a:p>
+            <a:pPr algn="ctr">
+              <a:lnSpc>
+                <a:spcPct val="108000"/>
+              </a:lnSpc>
+              <a:spcAft>
+                <a:spcPts val="0"/>
+              </a:spcAft>
+            </a:pPr>
+            <a:r>
+              <a:rPr sz="800" b="0">
+                <a:solidFill>
+                  <a:srgbClr val="062B27"/>
+                </a:solidFill>
+                <a:latin typeface="Consolas"/>
+              </a:rPr>
+              <a:t>8 HGB + iso</a:t>
+            </a:r>
+          </a:p>
+        </p:txBody>
+      </p:sp>
+      <p:sp>
+        <p:nvSpPr>
+          <p:cNvPr id="19" name="Can 18"/>
+          <p:cNvSpPr/>
+          <p:nvPr/>
+        </p:nvSpPr>
+        <p:spPr>
+          <a:xfrm>
+            <a:off x="8001000" y="2468880"/>
+            <a:ext cx="1280160" cy="822960"/>
+          </a:xfrm>
+          <a:prstGeom prst="can">
+            <a:avLst/>
+          </a:prstGeom>
+          <a:solidFill>
+            <a:srgbClr val="13202B"/>
+          </a:solidFill>
+          <a:ln w="15875">
+            <a:solidFill>
+              <a:srgbClr val="14B8A6"/>
+            </a:solidFill>
+          </a:ln>
+          <a:effectLst/>
+        </p:spPr>
+        <p:style>
+          <a:lnRef idx="1">
+            <a:schemeClr val="accent1"/>
+          </a:lnRef>
+          <a:fillRef idx="3">
+            <a:schemeClr val="accent1"/>
+          </a:fillRef>
+          <a:effectRef idx="2">
+            <a:schemeClr val="accent1"/>
+          </a:effectRef>
+          <a:fontRef idx="minor">
+            <a:schemeClr val="lt1"/>
+          </a:fontRef>
+        </p:style>
+        <p:txBody>
+          <a:bodyPr rtlCol="0" anchor="ctr"/>
+          <a:lstStyle/>
+          <a:p>
+            <a:pPr algn="ctr"/>
+          </a:p>
+        </p:txBody>
+      </p:sp>
+      <p:sp>
+        <p:nvSpPr>
+          <p:cNvPr id="20" name="TextBox 19"/>
+          <p:cNvSpPr txBox="1"/>
+          <p:nvPr/>
+        </p:nvSpPr>
+        <p:spPr>
+          <a:xfrm>
+            <a:off x="8001000" y="2748686"/>
+            <a:ext cx="1280160" cy="274320"/>
+          </a:xfrm>
+          <a:prstGeom prst="rect">
+            <a:avLst/>
+          </a:prstGeom>
+          <a:noFill/>
+        </p:spPr>
+        <p:txBody>
+          <a:bodyPr wrap="square" anchor="t" lIns="0" rIns="0" tIns="0" bIns="0">
+            <a:spAutoFit/>
+          </a:bodyPr>
+          <a:lstStyle/>
+          <a:p>
+            <a:pPr algn="ctr">
+              <a:lnSpc>
+                <a:spcPct val="108000"/>
+              </a:lnSpc>
+              <a:spcAft>
+                <a:spcPts val="0"/>
+              </a:spcAft>
+            </a:pPr>
+            <a:r>
+              <a:rPr sz="1200" b="1">
+                <a:solidFill>
+                  <a:srgbClr val="F2F7F6"/>
+                </a:solidFill>
+                <a:latin typeface="Georgia"/>
+              </a:rPr>
+              <a:t>Artifact</a:t>
+            </a:r>
+          </a:p>
+        </p:txBody>
+      </p:sp>
+      <p:sp>
+        <p:nvSpPr>
+          <p:cNvPr id="21" name="TextBox 20"/>
+          <p:cNvSpPr txBox="1"/>
+          <p:nvPr/>
+        </p:nvSpPr>
+        <p:spPr>
+          <a:xfrm>
+            <a:off x="8001000" y="2979115"/>
+            <a:ext cx="1280160" cy="237744"/>
+          </a:xfrm>
+          <a:prstGeom prst="rect">
+            <a:avLst/>
+          </a:prstGeom>
+          <a:noFill/>
+        </p:spPr>
+        <p:txBody>
+          <a:bodyPr wrap="square" anchor="t" lIns="0" rIns="0" tIns="0" bIns="0">
+            <a:spAutoFit/>
+          </a:bodyPr>
+          <a:lstStyle/>
+          <a:p>
+            <a:pPr algn="ctr">
+              <a:lnSpc>
+                <a:spcPct val="108000"/>
+              </a:lnSpc>
+              <a:spcAft>
+                <a:spcPts val="0"/>
+              </a:spcAft>
+            </a:pPr>
+            <a:r>
+              <a:rPr sz="800" b="0">
+                <a:solidFill>
+                  <a:srgbClr val="8CA3AD"/>
+                </a:solidFill>
+                <a:latin typeface="Consolas"/>
+              </a:rPr>
+              <a:t>pkl + metrics</a:t>
+            </a:r>
+          </a:p>
+        </p:txBody>
+      </p:sp>
+      <p:sp>
+        <p:nvSpPr>
+          <p:cNvPr id="22" name="Rectangle 21"/>
+          <p:cNvSpPr/>
+          <p:nvPr/>
+        </p:nvSpPr>
+        <p:spPr>
+          <a:xfrm>
+            <a:off x="9555480" y="2468880"/>
+            <a:ext cx="1874519" cy="822960"/>
+          </a:xfrm>
+          <a:prstGeom prst="rect">
+            <a:avLst/>
           </a:prstGeom>
           <a:solidFill>
             <a:srgbClr val="13202B"/>
@@ -13467,14 +13983,14 @@
       </p:sp>
       <p:sp>
         <p:nvSpPr>
-          <p:cNvPr id="11" name="TextBox 10"/>
+          <p:cNvPr id="23" name="TextBox 22"/>
           <p:cNvSpPr txBox="1"/>
           <p:nvPr/>
         </p:nvSpPr>
         <p:spPr>
           <a:xfrm>
-            <a:off x="3099816" y="2478024"/>
-            <a:ext cx="1691640" cy="347472"/>
+            <a:off x="9692640" y="2578608"/>
+            <a:ext cx="1600200" cy="640080"/>
           </a:xfrm>
           <a:prstGeom prst="rect">
             <a:avLst/>
@@ -13489,34 +14005,182 @@
           <a:p>
             <a:pPr algn="l">
               <a:lnSpc>
-                <a:spcPct val="108000"/>
-              </a:lnSpc>
-              <a:spcAft>
-                <a:spcPts val="800"/>
-              </a:spcAft>
-            </a:pPr>
-            <a:r>
-              <a:rPr sz="1500" b="1">
-                <a:solidFill>
-                  <a:srgbClr val="F2F7F6"/>
-                </a:solidFill>
-                <a:latin typeface="Consolas"/>
-              </a:rPr>
-              <a:t>ingest_v2.py</a:t>
-            </a:r>
-          </a:p>
-        </p:txBody>
-      </p:sp>
-      <p:sp>
-        <p:nvSpPr>
-          <p:cNvPr id="12" name="TextBox 11"/>
+                <a:spcPct val="105000"/>
+              </a:lnSpc>
+              <a:spcAft>
+                <a:spcPts val="0"/>
+              </a:spcAft>
+            </a:pPr>
+            <a:r>
+              <a:rPr sz="1100" b="0">
+                <a:solidFill>
+                  <a:srgbClr val="8CA3AD"/>
+                </a:solidFill>
+                <a:latin typeface="Georgia"/>
+              </a:rPr>
+              <a:t>re-run to retrain — weights stay local, mounted at deploy</a:t>
+            </a:r>
+          </a:p>
+        </p:txBody>
+      </p:sp>
+      <p:cxnSp>
+        <p:nvCxnSpPr>
+          <p:cNvPr id="24" name="Connector 23"/>
+          <p:cNvCxnSpPr/>
+          <p:nvPr/>
+        </p:nvCxnSpPr>
+        <p:spPr>
+          <a:xfrm>
+            <a:off x="2148840" y="2880360"/>
+            <a:ext cx="576072" cy="0"/>
+          </a:xfrm>
+          <a:prstGeom prst="line">
+            <a:avLst/>
+          </a:prstGeom>
+          <a:ln w="22225">
+            <a:solidFill>
+              <a:srgbClr val="14B8A6"/>
+            </a:solidFill>
+            <a:tailEnd type="triangle" w="med" len="med"/>
+          </a:ln>
+          <a:effectLst/>
+        </p:spPr>
+        <p:style>
+          <a:lnRef idx="2">
+            <a:schemeClr val="accent1"/>
+          </a:lnRef>
+          <a:fillRef idx="0">
+            <a:schemeClr val="accent1"/>
+          </a:fillRef>
+          <a:effectRef idx="1">
+            <a:schemeClr val="accent1"/>
+          </a:effectRef>
+          <a:fontRef idx="minor">
+            <a:schemeClr val="tx1"/>
+          </a:fontRef>
+        </p:style>
+      </p:cxnSp>
+      <p:cxnSp>
+        <p:nvCxnSpPr>
+          <p:cNvPr id="25" name="Connector 24"/>
+          <p:cNvCxnSpPr/>
+          <p:nvPr/>
+        </p:nvCxnSpPr>
+        <p:spPr>
+          <a:xfrm>
+            <a:off x="3858768" y="2880360"/>
+            <a:ext cx="548640" cy="0"/>
+          </a:xfrm>
+          <a:prstGeom prst="line">
+            <a:avLst/>
+          </a:prstGeom>
+          <a:ln w="22225">
+            <a:solidFill>
+              <a:srgbClr val="14B8A6"/>
+            </a:solidFill>
+            <a:tailEnd type="triangle" w="med" len="med"/>
+          </a:ln>
+          <a:effectLst/>
+        </p:spPr>
+        <p:style>
+          <a:lnRef idx="2">
+            <a:schemeClr val="accent1"/>
+          </a:lnRef>
+          <a:fillRef idx="0">
+            <a:schemeClr val="accent1"/>
+          </a:fillRef>
+          <a:effectRef idx="1">
+            <a:schemeClr val="accent1"/>
+          </a:effectRef>
+          <a:fontRef idx="minor">
+            <a:schemeClr val="tx1"/>
+          </a:fontRef>
+        </p:style>
+      </p:cxnSp>
+      <p:cxnSp>
+        <p:nvCxnSpPr>
+          <p:cNvPr id="26" name="Connector 25"/>
+          <p:cNvCxnSpPr/>
+          <p:nvPr/>
+        </p:nvCxnSpPr>
+        <p:spPr>
+          <a:xfrm>
+            <a:off x="5742432" y="2880360"/>
+            <a:ext cx="548640" cy="0"/>
+          </a:xfrm>
+          <a:prstGeom prst="line">
+            <a:avLst/>
+          </a:prstGeom>
+          <a:ln w="22225">
+            <a:solidFill>
+              <a:srgbClr val="14B8A6"/>
+            </a:solidFill>
+            <a:tailEnd type="triangle" w="med" len="med"/>
+          </a:ln>
+          <a:effectLst/>
+        </p:spPr>
+        <p:style>
+          <a:lnRef idx="2">
+            <a:schemeClr val="accent1"/>
+          </a:lnRef>
+          <a:fillRef idx="0">
+            <a:schemeClr val="accent1"/>
+          </a:fillRef>
+          <a:effectRef idx="1">
+            <a:schemeClr val="accent1"/>
+          </a:effectRef>
+          <a:fontRef idx="minor">
+            <a:schemeClr val="tx1"/>
+          </a:fontRef>
+        </p:style>
+      </p:cxnSp>
+      <p:cxnSp>
+        <p:nvCxnSpPr>
+          <p:cNvPr id="27" name="Connector 26"/>
+          <p:cNvCxnSpPr/>
+          <p:nvPr/>
+        </p:nvCxnSpPr>
+        <p:spPr>
+          <a:xfrm>
+            <a:off x="7424927" y="2880360"/>
+            <a:ext cx="548641" cy="0"/>
+          </a:xfrm>
+          <a:prstGeom prst="line">
+            <a:avLst/>
+          </a:prstGeom>
+          <a:ln w="22225">
+            <a:solidFill>
+              <a:srgbClr val="14B8A6"/>
+            </a:solidFill>
+            <a:tailEnd type="triangle" w="med" len="med"/>
+          </a:ln>
+          <a:effectLst/>
+        </p:spPr>
+        <p:style>
+          <a:lnRef idx="2">
+            <a:schemeClr val="accent1"/>
+          </a:lnRef>
+          <a:fillRef idx="0">
+            <a:schemeClr val="accent1"/>
+          </a:fillRef>
+          <a:effectRef idx="1">
+            <a:schemeClr val="accent1"/>
+          </a:effectRef>
+          <a:fontRef idx="minor">
+            <a:schemeClr val="tx1"/>
+          </a:fontRef>
+        </p:style>
+      </p:cxnSp>
+      <p:sp>
+        <p:nvSpPr>
+          <p:cNvPr id="28" name="TextBox 27"/>
           <p:cNvSpPr txBox="1"/>
           <p:nvPr/>
         </p:nvSpPr>
         <p:spPr>
           <a:xfrm>
-            <a:off x="3099816" y="2852928"/>
-            <a:ext cx="1691640" cy="347472"/>
+            <a:off x="1938528" y="2578608"/>
+            <a:ext cx="1005840" cy="274320"/>
           </a:xfrm>
           <a:prstGeom prst="rect">
             <a:avLst/>
@@ -13529,6 +14193,218 @@
           </a:bodyPr>
           <a:lstStyle/>
           <a:p>
+            <a:pPr algn="ctr">
+              <a:lnSpc>
+                <a:spcPct val="108000"/>
+              </a:lnSpc>
+              <a:spcAft>
+                <a:spcPts val="0"/>
+              </a:spcAft>
+            </a:pPr>
+            <a:r>
+              <a:rPr sz="900" b="0">
+                <a:solidFill>
+                  <a:srgbClr val="8CA3AD"/>
+                </a:solidFill>
+                <a:latin typeface="Consolas"/>
+              </a:rPr>
+              <a:t>raw data</a:t>
+            </a:r>
+          </a:p>
+        </p:txBody>
+      </p:sp>
+      <p:sp>
+        <p:nvSpPr>
+          <p:cNvPr id="29" name="TextBox 28"/>
+          <p:cNvSpPr txBox="1"/>
+          <p:nvPr/>
+        </p:nvSpPr>
+        <p:spPr>
+          <a:xfrm>
+            <a:off x="3630168" y="2578608"/>
+            <a:ext cx="1005840" cy="274320"/>
+          </a:xfrm>
+          <a:prstGeom prst="rect">
+            <a:avLst/>
+          </a:prstGeom>
+          <a:noFill/>
+        </p:spPr>
+        <p:txBody>
+          <a:bodyPr wrap="square" anchor="t" lIns="0" rIns="0" tIns="0" bIns="0">
+            <a:spAutoFit/>
+          </a:bodyPr>
+          <a:lstStyle/>
+          <a:p>
+            <a:pPr algn="ctr">
+              <a:lnSpc>
+                <a:spcPct val="108000"/>
+              </a:lnSpc>
+              <a:spcAft>
+                <a:spcPts val="0"/>
+              </a:spcAft>
+            </a:pPr>
+            <a:r>
+              <a:rPr sz="900" b="0">
+                <a:solidFill>
+                  <a:srgbClr val="8CA3AD"/>
+                </a:solidFill>
+                <a:latin typeface="Consolas"/>
+              </a:rPr>
+              <a:t>records</a:t>
+            </a:r>
+          </a:p>
+        </p:txBody>
+      </p:sp>
+      <p:sp>
+        <p:nvSpPr>
+          <p:cNvPr id="30" name="TextBox 29"/>
+          <p:cNvSpPr txBox="1"/>
+          <p:nvPr/>
+        </p:nvSpPr>
+        <p:spPr>
+          <a:xfrm>
+            <a:off x="5513832" y="2578608"/>
+            <a:ext cx="1005840" cy="274320"/>
+          </a:xfrm>
+          <a:prstGeom prst="rect">
+            <a:avLst/>
+          </a:prstGeom>
+          <a:noFill/>
+        </p:spPr>
+        <p:txBody>
+          <a:bodyPr wrap="square" anchor="t" lIns="0" rIns="0" tIns="0" bIns="0">
+            <a:spAutoFit/>
+          </a:bodyPr>
+          <a:lstStyle/>
+          <a:p>
+            <a:pPr algn="ctr">
+              <a:lnSpc>
+                <a:spcPct val="108000"/>
+              </a:lnSpc>
+              <a:spcAft>
+                <a:spcPts val="0"/>
+              </a:spcAft>
+            </a:pPr>
+            <a:r>
+              <a:rPr sz="900" b="0">
+                <a:solidFill>
+                  <a:srgbClr val="8CA3AD"/>
+                </a:solidFill>
+                <a:latin typeface="Consolas"/>
+              </a:rPr>
+              <a:t>features</a:t>
+            </a:r>
+          </a:p>
+        </p:txBody>
+      </p:sp>
+      <p:sp>
+        <p:nvSpPr>
+          <p:cNvPr id="31" name="TextBox 30"/>
+          <p:cNvSpPr txBox="1"/>
+          <p:nvPr/>
+        </p:nvSpPr>
+        <p:spPr>
+          <a:xfrm>
+            <a:off x="7196328" y="2578608"/>
+            <a:ext cx="1005840" cy="274320"/>
+          </a:xfrm>
+          <a:prstGeom prst="rect">
+            <a:avLst/>
+          </a:prstGeom>
+          <a:noFill/>
+        </p:spPr>
+        <p:txBody>
+          <a:bodyPr wrap="square" anchor="t" lIns="0" rIns="0" tIns="0" bIns="0">
+            <a:spAutoFit/>
+          </a:bodyPr>
+          <a:lstStyle/>
+          <a:p>
+            <a:pPr algn="ctr">
+              <a:lnSpc>
+                <a:spcPct val="108000"/>
+              </a:lnSpc>
+              <a:spcAft>
+                <a:spcPts val="0"/>
+              </a:spcAft>
+            </a:pPr>
+            <a:r>
+              <a:rPr sz="900" b="0">
+                <a:solidFill>
+                  <a:srgbClr val="8CA3AD"/>
+                </a:solidFill>
+                <a:latin typeface="Consolas"/>
+              </a:rPr>
+              <a:t>weights</a:t>
+            </a:r>
+          </a:p>
+        </p:txBody>
+      </p:sp>
+      <p:sp>
+        <p:nvSpPr>
+          <p:cNvPr id="32" name="Rectangle 31"/>
+          <p:cNvSpPr/>
+          <p:nvPr/>
+        </p:nvSpPr>
+        <p:spPr>
+          <a:xfrm>
+            <a:off x="822960" y="4014216"/>
+            <a:ext cx="109728" cy="109728"/>
+          </a:xfrm>
+          <a:prstGeom prst="rect">
+            <a:avLst/>
+          </a:prstGeom>
+          <a:solidFill>
+            <a:srgbClr val="14B8A6"/>
+          </a:solidFill>
+          <a:ln>
+            <a:noFill/>
+          </a:ln>
+          <a:effectLst/>
+        </p:spPr>
+        <p:style>
+          <a:lnRef idx="1">
+            <a:schemeClr val="accent1"/>
+          </a:lnRef>
+          <a:fillRef idx="3">
+            <a:schemeClr val="accent1"/>
+          </a:fillRef>
+          <a:effectRef idx="2">
+            <a:schemeClr val="accent1"/>
+          </a:effectRef>
+          <a:fontRef idx="minor">
+            <a:schemeClr val="lt1"/>
+          </a:fontRef>
+        </p:style>
+        <p:txBody>
+          <a:bodyPr rtlCol="0" anchor="ctr"/>
+          <a:lstStyle/>
+          <a:p>
+            <a:pPr algn="ctr"/>
+          </a:p>
+        </p:txBody>
+      </p:sp>
+      <p:sp>
+        <p:nvSpPr>
+          <p:cNvPr id="33" name="TextBox 32"/>
+          <p:cNvSpPr txBox="1"/>
+          <p:nvPr/>
+        </p:nvSpPr>
+        <p:spPr>
+          <a:xfrm>
+            <a:off x="1078992" y="3950208"/>
+            <a:ext cx="6400800" cy="365760"/>
+          </a:xfrm>
+          <a:prstGeom prst="rect">
+            <a:avLst/>
+          </a:prstGeom>
+          <a:noFill/>
+        </p:spPr>
+        <p:txBody>
+          <a:bodyPr wrap="square" anchor="t" lIns="0" rIns="0" tIns="0" bIns="0">
+            <a:spAutoFit/>
+          </a:bodyPr>
+          <a:lstStyle/>
+          <a:p>
             <a:pPr algn="l">
               <a:lnSpc>
                 <a:spcPct val="108000"/>
@@ -13538,32 +14414,30 @@
               </a:spcAft>
             </a:pPr>
             <a:r>
-              <a:rPr sz="1100" b="0">
-                <a:solidFill>
-                  <a:srgbClr val="8CA3AD"/>
+              <a:rPr sz="1300" b="1">
+                <a:solidFill>
+                  <a:srgbClr val="2DD4BF"/>
                 </a:solidFill>
                 <a:latin typeface="Consolas"/>
               </a:rPr>
-              <a:t>clean · 201 features</a:t>
-            </a:r>
-          </a:p>
-        </p:txBody>
-      </p:sp>
-      <p:sp>
-        <p:nvSpPr>
-          <p:cNvPr id="13" name="Rounded Rectangle 12"/>
+              <a:t>LIVE — EVERY REQUEST</a:t>
+            </a:r>
+          </a:p>
+        </p:txBody>
+      </p:sp>
+      <p:sp>
+        <p:nvSpPr>
+          <p:cNvPr id="34" name="Rectangle 33"/>
           <p:cNvSpPr/>
           <p:nvPr/>
         </p:nvSpPr>
         <p:spPr>
           <a:xfrm>
-            <a:off x="5166360" y="2359152"/>
-            <a:ext cx="1901952" cy="896112"/>
-          </a:xfrm>
-          <a:prstGeom prst="roundRect">
-            <a:avLst>
-              <a:gd name="adj" fmla="val 5000"/>
-            </a:avLst>
+            <a:off x="777240" y="4553712"/>
+            <a:ext cx="1371600" cy="777240"/>
+          </a:xfrm>
+          <a:prstGeom prst="rect">
+            <a:avLst/>
           </a:prstGeom>
           <a:solidFill>
             <a:srgbClr val="13202B"/>
@@ -13597,14 +14471,14 @@
       </p:sp>
       <p:sp>
         <p:nvSpPr>
-          <p:cNvPr id="14" name="TextBox 13"/>
+          <p:cNvPr id="35" name="TextBox 34"/>
           <p:cNvSpPr txBox="1"/>
           <p:nvPr/>
         </p:nvSpPr>
         <p:spPr>
           <a:xfrm>
-            <a:off x="5294376" y="2478024"/>
-            <a:ext cx="1691640" cy="347472"/>
+            <a:off x="850392" y="4681728"/>
+            <a:ext cx="1225296" cy="320040"/>
           </a:xfrm>
           <a:prstGeom prst="rect">
             <a:avLst/>
@@ -13617,36 +14491,36 @@
           </a:bodyPr>
           <a:lstStyle/>
           <a:p>
-            <a:pPr algn="l">
-              <a:lnSpc>
-                <a:spcPct val="108000"/>
-              </a:lnSpc>
-              <a:spcAft>
-                <a:spcPts val="800"/>
-              </a:spcAft>
-            </a:pPr>
-            <a:r>
-              <a:rPr sz="1500" b="1">
+            <a:pPr algn="ctr">
+              <a:lnSpc>
+                <a:spcPct val="108000"/>
+              </a:lnSpc>
+              <a:spcAft>
+                <a:spcPts val="0"/>
+              </a:spcAft>
+            </a:pPr>
+            <a:r>
+              <a:rPr sz="1150" b="1">
                 <a:solidFill>
                   <a:srgbClr val="F2F7F6"/>
                 </a:solidFill>
-                <a:latin typeface="Consolas"/>
-              </a:rPr>
-              <a:t>corpus</a:t>
-            </a:r>
-          </a:p>
-        </p:txBody>
-      </p:sp>
-      <p:sp>
-        <p:nvSpPr>
-          <p:cNvPr id="15" name="TextBox 14"/>
+                <a:latin typeface="Georgia"/>
+              </a:rPr>
+              <a:t>Genomic report</a:t>
+            </a:r>
+          </a:p>
+        </p:txBody>
+      </p:sp>
+      <p:sp>
+        <p:nvSpPr>
+          <p:cNvPr id="36" name="TextBox 35"/>
           <p:cNvSpPr txBox="1"/>
           <p:nvPr/>
         </p:nvSpPr>
         <p:spPr>
           <a:xfrm>
-            <a:off x="5294376" y="2852928"/>
-            <a:ext cx="1691640" cy="347472"/>
+            <a:off x="850392" y="5010912"/>
+            <a:ext cx="1225296" cy="256032"/>
           </a:xfrm>
           <a:prstGeom prst="rect">
             <a:avLst/>
@@ -13659,41 +14533,429 @@
           </a:bodyPr>
           <a:lstStyle/>
           <a:p>
-            <a:pPr algn="l">
-              <a:lnSpc>
-                <a:spcPct val="108000"/>
-              </a:lnSpc>
-              <a:spcAft>
-                <a:spcPts val="800"/>
-              </a:spcAft>
-            </a:pPr>
-            <a:r>
-              <a:rPr sz="1100" b="0">
+            <a:pPr algn="ctr">
+              <a:lnSpc>
+                <a:spcPct val="108000"/>
+              </a:lnSpc>
+              <a:spcAft>
+                <a:spcPts val="0"/>
+              </a:spcAft>
+            </a:pPr>
+            <a:r>
+              <a:rPr sz="900" b="0">
                 <a:solidFill>
                   <a:srgbClr val="8CA3AD"/>
                 </a:solidFill>
                 <a:latin typeface="Consolas"/>
               </a:rPr>
-              <a:t>26,064 records</a:t>
-            </a:r>
-          </a:p>
-        </p:txBody>
-      </p:sp>
-      <p:sp>
-        <p:nvSpPr>
-          <p:cNvPr id="16" name="Rounded Rectangle 15"/>
+              <a:t>upload · worklist</a:t>
+            </a:r>
+          </a:p>
+        </p:txBody>
+      </p:sp>
+      <p:sp>
+        <p:nvSpPr>
+          <p:cNvPr id="37" name="Oval 36"/>
           <p:cNvSpPr/>
           <p:nvPr/>
         </p:nvSpPr>
         <p:spPr>
           <a:xfrm>
-            <a:off x="7360920" y="2359152"/>
-            <a:ext cx="1901952" cy="896112"/>
-          </a:xfrm>
-          <a:prstGeom prst="roundRect">
-            <a:avLst>
-              <a:gd name="adj" fmla="val 5000"/>
-            </a:avLst>
+            <a:off x="2743200" y="4389120"/>
+            <a:ext cx="1097280" cy="1097280"/>
+          </a:xfrm>
+          <a:prstGeom prst="ellipse">
+            <a:avLst/>
+          </a:prstGeom>
+          <a:solidFill>
+            <a:srgbClr val="14B8A6"/>
+          </a:solidFill>
+          <a:ln>
+            <a:solidFill>
+              <a:srgbClr val="14B8A6"/>
+            </a:solidFill>
+          </a:ln>
+          <a:effectLst/>
+        </p:spPr>
+        <p:style>
+          <a:lnRef idx="1">
+            <a:schemeClr val="accent1"/>
+          </a:lnRef>
+          <a:fillRef idx="3">
+            <a:schemeClr val="accent1"/>
+          </a:fillRef>
+          <a:effectRef idx="2">
+            <a:schemeClr val="accent1"/>
+          </a:effectRef>
+          <a:fontRef idx="minor">
+            <a:schemeClr val="lt1"/>
+          </a:fontRef>
+        </p:style>
+        <p:txBody>
+          <a:bodyPr rtlCol="0" anchor="ctr"/>
+          <a:lstStyle/>
+          <a:p>
+            <a:pPr algn="ctr"/>
+          </a:p>
+        </p:txBody>
+      </p:sp>
+      <p:sp>
+        <p:nvSpPr>
+          <p:cNvPr id="38" name="TextBox 37"/>
+          <p:cNvSpPr txBox="1"/>
+          <p:nvPr/>
+        </p:nvSpPr>
+        <p:spPr>
+          <a:xfrm>
+            <a:off x="2743200" y="4663440"/>
+            <a:ext cx="1097280" cy="292608"/>
+          </a:xfrm>
+          <a:prstGeom prst="rect">
+            <a:avLst/>
+          </a:prstGeom>
+          <a:noFill/>
+        </p:spPr>
+        <p:txBody>
+          <a:bodyPr wrap="square" anchor="t" lIns="0" rIns="0" tIns="0" bIns="0">
+            <a:spAutoFit/>
+          </a:bodyPr>
+          <a:lstStyle/>
+          <a:p>
+            <a:pPr algn="ctr">
+              <a:lnSpc>
+                <a:spcPct val="108000"/>
+              </a:lnSpc>
+              <a:spcAft>
+                <a:spcPts val="0"/>
+              </a:spcAft>
+            </a:pPr>
+            <a:r>
+              <a:rPr sz="1200" b="1">
+                <a:solidFill>
+                  <a:srgbClr val="062B27"/>
+                </a:solidFill>
+                <a:latin typeface="Georgia"/>
+              </a:rPr>
+              <a:t>Normalize</a:t>
+            </a:r>
+          </a:p>
+        </p:txBody>
+      </p:sp>
+      <p:sp>
+        <p:nvSpPr>
+          <p:cNvPr id="39" name="TextBox 38"/>
+          <p:cNvSpPr txBox="1"/>
+          <p:nvPr/>
+        </p:nvSpPr>
+        <p:spPr>
+          <a:xfrm>
+            <a:off x="2743200" y="4983480"/>
+            <a:ext cx="1097280" cy="237744"/>
+          </a:xfrm>
+          <a:prstGeom prst="rect">
+            <a:avLst/>
+          </a:prstGeom>
+          <a:noFill/>
+        </p:spPr>
+        <p:txBody>
+          <a:bodyPr wrap="square" anchor="t" lIns="0" rIns="0" tIns="0" bIns="0">
+            <a:spAutoFit/>
+          </a:bodyPr>
+          <a:lstStyle/>
+          <a:p>
+            <a:pPr algn="ctr">
+              <a:lnSpc>
+                <a:spcPct val="108000"/>
+              </a:lnSpc>
+              <a:spcAft>
+                <a:spcPts val="0"/>
+              </a:spcAft>
+            </a:pPr>
+            <a:r>
+              <a:rPr sz="800" b="0">
+                <a:solidFill>
+                  <a:srgbClr val="062B27"/>
+                </a:solidFill>
+                <a:latin typeface="Consolas"/>
+              </a:rPr>
+              <a:t>features.py</a:t>
+            </a:r>
+          </a:p>
+        </p:txBody>
+      </p:sp>
+      <p:sp>
+        <p:nvSpPr>
+          <p:cNvPr id="40" name="Oval 39"/>
+          <p:cNvSpPr/>
+          <p:nvPr/>
+        </p:nvSpPr>
+        <p:spPr>
+          <a:xfrm>
+            <a:off x="4407408" y="4389120"/>
+            <a:ext cx="1097280" cy="1097280"/>
+          </a:xfrm>
+          <a:prstGeom prst="ellipse">
+            <a:avLst/>
+          </a:prstGeom>
+          <a:solidFill>
+            <a:srgbClr val="14B8A6"/>
+          </a:solidFill>
+          <a:ln>
+            <a:solidFill>
+              <a:srgbClr val="14B8A6"/>
+            </a:solidFill>
+          </a:ln>
+          <a:effectLst/>
+        </p:spPr>
+        <p:style>
+          <a:lnRef idx="1">
+            <a:schemeClr val="accent1"/>
+          </a:lnRef>
+          <a:fillRef idx="3">
+            <a:schemeClr val="accent1"/>
+          </a:fillRef>
+          <a:effectRef idx="2">
+            <a:schemeClr val="accent1"/>
+          </a:effectRef>
+          <a:fontRef idx="minor">
+            <a:schemeClr val="lt1"/>
+          </a:fontRef>
+        </p:style>
+        <p:txBody>
+          <a:bodyPr rtlCol="0" anchor="ctr"/>
+          <a:lstStyle/>
+          <a:p>
+            <a:pPr algn="ctr"/>
+          </a:p>
+        </p:txBody>
+      </p:sp>
+      <p:sp>
+        <p:nvSpPr>
+          <p:cNvPr id="41" name="TextBox 40"/>
+          <p:cNvSpPr txBox="1"/>
+          <p:nvPr/>
+        </p:nvSpPr>
+        <p:spPr>
+          <a:xfrm>
+            <a:off x="4407408" y="4663440"/>
+            <a:ext cx="1097280" cy="292608"/>
+          </a:xfrm>
+          <a:prstGeom prst="rect">
+            <a:avLst/>
+          </a:prstGeom>
+          <a:noFill/>
+        </p:spPr>
+        <p:txBody>
+          <a:bodyPr wrap="square" anchor="t" lIns="0" rIns="0" tIns="0" bIns="0">
+            <a:spAutoFit/>
+          </a:bodyPr>
+          <a:lstStyle/>
+          <a:p>
+            <a:pPr algn="ctr">
+              <a:lnSpc>
+                <a:spcPct val="108000"/>
+              </a:lnSpc>
+              <a:spcAft>
+                <a:spcPts val="0"/>
+              </a:spcAft>
+            </a:pPr>
+            <a:r>
+              <a:rPr sz="1200" b="1">
+                <a:solidFill>
+                  <a:srgbClr val="062B27"/>
+                </a:solidFill>
+                <a:latin typeface="Georgia"/>
+              </a:rPr>
+              <a:t>Predict</a:t>
+            </a:r>
+          </a:p>
+        </p:txBody>
+      </p:sp>
+      <p:sp>
+        <p:nvSpPr>
+          <p:cNvPr id="42" name="TextBox 41"/>
+          <p:cNvSpPr txBox="1"/>
+          <p:nvPr/>
+        </p:nvSpPr>
+        <p:spPr>
+          <a:xfrm>
+            <a:off x="4407408" y="4983480"/>
+            <a:ext cx="1097280" cy="237744"/>
+          </a:xfrm>
+          <a:prstGeom prst="rect">
+            <a:avLst/>
+          </a:prstGeom>
+          <a:noFill/>
+        </p:spPr>
+        <p:txBody>
+          <a:bodyPr wrap="square" anchor="t" lIns="0" rIns="0" tIns="0" bIns="0">
+            <a:spAutoFit/>
+          </a:bodyPr>
+          <a:lstStyle/>
+          <a:p>
+            <a:pPr algn="ctr">
+              <a:lnSpc>
+                <a:spcPct val="108000"/>
+              </a:lnSpc>
+              <a:spcAft>
+                <a:spcPts val="0"/>
+              </a:spcAft>
+            </a:pPr>
+            <a:r>
+              <a:rPr sz="800" b="0">
+                <a:solidFill>
+                  <a:srgbClr val="062B27"/>
+                </a:solidFill>
+                <a:latin typeface="Consolas"/>
+              </a:rPr>
+              <a:t>predictor.py</a:t>
+            </a:r>
+          </a:p>
+        </p:txBody>
+      </p:sp>
+      <p:sp>
+        <p:nvSpPr>
+          <p:cNvPr id="43" name="Oval 42"/>
+          <p:cNvSpPr/>
+          <p:nvPr/>
+        </p:nvSpPr>
+        <p:spPr>
+          <a:xfrm>
+            <a:off x="6071616" y="4389120"/>
+            <a:ext cx="1097280" cy="1097280"/>
+          </a:xfrm>
+          <a:prstGeom prst="ellipse">
+            <a:avLst/>
+          </a:prstGeom>
+          <a:solidFill>
+            <a:srgbClr val="14B8A6"/>
+          </a:solidFill>
+          <a:ln>
+            <a:solidFill>
+              <a:srgbClr val="14B8A6"/>
+            </a:solidFill>
+          </a:ln>
+          <a:effectLst/>
+        </p:spPr>
+        <p:style>
+          <a:lnRef idx="1">
+            <a:schemeClr val="accent1"/>
+          </a:lnRef>
+          <a:fillRef idx="3">
+            <a:schemeClr val="accent1"/>
+          </a:fillRef>
+          <a:effectRef idx="2">
+            <a:schemeClr val="accent1"/>
+          </a:effectRef>
+          <a:fontRef idx="minor">
+            <a:schemeClr val="lt1"/>
+          </a:fontRef>
+        </p:style>
+        <p:txBody>
+          <a:bodyPr rtlCol="0" anchor="ctr"/>
+          <a:lstStyle/>
+          <a:p>
+            <a:pPr algn="ctr"/>
+          </a:p>
+        </p:txBody>
+      </p:sp>
+      <p:sp>
+        <p:nvSpPr>
+          <p:cNvPr id="44" name="TextBox 43"/>
+          <p:cNvSpPr txBox="1"/>
+          <p:nvPr/>
+        </p:nvSpPr>
+        <p:spPr>
+          <a:xfrm>
+            <a:off x="6071616" y="4663440"/>
+            <a:ext cx="1097280" cy="292608"/>
+          </a:xfrm>
+          <a:prstGeom prst="rect">
+            <a:avLst/>
+          </a:prstGeom>
+          <a:noFill/>
+        </p:spPr>
+        <p:txBody>
+          <a:bodyPr wrap="square" anchor="t" lIns="0" rIns="0" tIns="0" bIns="0">
+            <a:spAutoFit/>
+          </a:bodyPr>
+          <a:lstStyle/>
+          <a:p>
+            <a:pPr algn="ctr">
+              <a:lnSpc>
+                <a:spcPct val="108000"/>
+              </a:lnSpc>
+              <a:spcAft>
+                <a:spcPts val="0"/>
+              </a:spcAft>
+            </a:pPr>
+            <a:r>
+              <a:rPr sz="1200" b="1">
+                <a:solidFill>
+                  <a:srgbClr val="062B27"/>
+                </a:solidFill>
+                <a:latin typeface="Georgia"/>
+              </a:rPr>
+              <a:t>Match</a:t>
+            </a:r>
+          </a:p>
+        </p:txBody>
+      </p:sp>
+      <p:sp>
+        <p:nvSpPr>
+          <p:cNvPr id="45" name="TextBox 44"/>
+          <p:cNvSpPr txBox="1"/>
+          <p:nvPr/>
+        </p:nvSpPr>
+        <p:spPr>
+          <a:xfrm>
+            <a:off x="6071616" y="4983480"/>
+            <a:ext cx="1097280" cy="237744"/>
+          </a:xfrm>
+          <a:prstGeom prst="rect">
+            <a:avLst/>
+          </a:prstGeom>
+          <a:noFill/>
+        </p:spPr>
+        <p:txBody>
+          <a:bodyPr wrap="square" anchor="t" lIns="0" rIns="0" tIns="0" bIns="0">
+            <a:spAutoFit/>
+          </a:bodyPr>
+          <a:lstStyle/>
+          <a:p>
+            <a:pPr algn="ctr">
+              <a:lnSpc>
+                <a:spcPct val="108000"/>
+              </a:lnSpc>
+              <a:spcAft>
+                <a:spcPts val="0"/>
+              </a:spcAft>
+            </a:pPr>
+            <a:r>
+              <a:rPr sz="800" b="0">
+                <a:solidFill>
+                  <a:srgbClr val="062B27"/>
+                </a:solidFill>
+                <a:latin typeface="Consolas"/>
+              </a:rPr>
+              <a:t>twins · cohorts</a:t>
+            </a:r>
+          </a:p>
+        </p:txBody>
+      </p:sp>
+      <p:sp>
+        <p:nvSpPr>
+          <p:cNvPr id="46" name="Rectangle 45"/>
+          <p:cNvSpPr/>
+          <p:nvPr/>
+        </p:nvSpPr>
+        <p:spPr>
+          <a:xfrm>
+            <a:off x="8001000" y="4553712"/>
+            <a:ext cx="1371600" cy="777240"/>
+          </a:xfrm>
+          <a:prstGeom prst="rect">
+            <a:avLst/>
           </a:prstGeom>
           <a:solidFill>
             <a:srgbClr val="13202B"/>
@@ -13727,14 +14989,14 @@
       </p:sp>
       <p:sp>
         <p:nvSpPr>
-          <p:cNvPr id="17" name="TextBox 16"/>
+          <p:cNvPr id="47" name="TextBox 46"/>
           <p:cNvSpPr txBox="1"/>
           <p:nvPr/>
         </p:nvSpPr>
         <p:spPr>
           <a:xfrm>
-            <a:off x="7488936" y="2478024"/>
-            <a:ext cx="1691640" cy="347472"/>
+            <a:off x="8074152" y="4681728"/>
+            <a:ext cx="1225296" cy="320040"/>
           </a:xfrm>
           <a:prstGeom prst="rect">
             <a:avLst/>
@@ -13747,36 +15009,36 @@
           </a:bodyPr>
           <a:lstStyle/>
           <a:p>
-            <a:pPr algn="l">
-              <a:lnSpc>
-                <a:spcPct val="108000"/>
-              </a:lnSpc>
-              <a:spcAft>
-                <a:spcPts val="800"/>
-              </a:spcAft>
-            </a:pPr>
-            <a:r>
-              <a:rPr sz="1500" b="1">
+            <a:pPr algn="ctr">
+              <a:lnSpc>
+                <a:spcPct val="108000"/>
+              </a:lnSpc>
+              <a:spcAft>
+                <a:spcPts val="0"/>
+              </a:spcAft>
+            </a:pPr>
+            <a:r>
+              <a:rPr sz="1150" b="1">
                 <a:solidFill>
                   <a:srgbClr val="F2F7F6"/>
                 </a:solidFill>
-                <a:latin typeface="Consolas"/>
-              </a:rPr>
-              <a:t>train_v2.py</a:t>
-            </a:r>
-          </a:p>
-        </p:txBody>
-      </p:sp>
-      <p:sp>
-        <p:nvSpPr>
-          <p:cNvPr id="18" name="TextBox 17"/>
+                <a:latin typeface="Georgia"/>
+              </a:rPr>
+              <a:t>Streamlit UI</a:t>
+            </a:r>
+          </a:p>
+        </p:txBody>
+      </p:sp>
+      <p:sp>
+        <p:nvSpPr>
+          <p:cNvPr id="48" name="TextBox 47"/>
           <p:cNvSpPr txBox="1"/>
           <p:nvPr/>
         </p:nvSpPr>
         <p:spPr>
           <a:xfrm>
-            <a:off x="7488936" y="2852928"/>
-            <a:ext cx="1691640" cy="347472"/>
+            <a:off x="8074152" y="5010912"/>
+            <a:ext cx="1225296" cy="256032"/>
           </a:xfrm>
           <a:prstGeom prst="rect">
             <a:avLst/>
@@ -13789,41 +15051,39 @@
           </a:bodyPr>
           <a:lstStyle/>
           <a:p>
-            <a:pPr algn="l">
-              <a:lnSpc>
-                <a:spcPct val="108000"/>
-              </a:lnSpc>
-              <a:spcAft>
-                <a:spcPts val="800"/>
-              </a:spcAft>
-            </a:pPr>
-            <a:r>
-              <a:rPr sz="1100" b="0">
+            <a:pPr algn="ctr">
+              <a:lnSpc>
+                <a:spcPct val="108000"/>
+              </a:lnSpc>
+              <a:spcAft>
+                <a:spcPts val="0"/>
+              </a:spcAft>
+            </a:pPr>
+            <a:r>
+              <a:rPr sz="900" b="0">
                 <a:solidFill>
                   <a:srgbClr val="8CA3AD"/>
                 </a:solidFill>
                 <a:latin typeface="Consolas"/>
               </a:rPr>
-              <a:t>8 models, calibrated</a:t>
-            </a:r>
-          </a:p>
-        </p:txBody>
-      </p:sp>
-      <p:sp>
-        <p:nvSpPr>
-          <p:cNvPr id="19" name="Rounded Rectangle 18"/>
+              <a:t>8 tabs · Flask</a:t>
+            </a:r>
+          </a:p>
+        </p:txBody>
+      </p:sp>
+      <p:sp>
+        <p:nvSpPr>
+          <p:cNvPr id="49" name="Rectangle 48"/>
           <p:cNvSpPr/>
           <p:nvPr/>
         </p:nvSpPr>
         <p:spPr>
           <a:xfrm>
-            <a:off x="9555480" y="2359152"/>
-            <a:ext cx="1901952" cy="896112"/>
-          </a:xfrm>
-          <a:prstGeom prst="roundRect">
-            <a:avLst>
-              <a:gd name="adj" fmla="val 5000"/>
-            </a:avLst>
+            <a:off x="9829800" y="4553712"/>
+            <a:ext cx="1371600" cy="777240"/>
+          </a:xfrm>
+          <a:prstGeom prst="rect">
+            <a:avLst/>
           </a:prstGeom>
           <a:solidFill>
             <a:srgbClr val="13202B"/>
@@ -13857,14 +15117,14 @@
       </p:sp>
       <p:sp>
         <p:nvSpPr>
-          <p:cNvPr id="20" name="TextBox 19"/>
+          <p:cNvPr id="50" name="TextBox 49"/>
           <p:cNvSpPr txBox="1"/>
           <p:nvPr/>
         </p:nvSpPr>
         <p:spPr>
           <a:xfrm>
-            <a:off x="9683496" y="2478024"/>
-            <a:ext cx="1691640" cy="347472"/>
+            <a:off x="9902952" y="4681728"/>
+            <a:ext cx="1225296" cy="320040"/>
           </a:xfrm>
           <a:prstGeom prst="rect">
             <a:avLst/>
@@ -13877,36 +15137,36 @@
           </a:bodyPr>
           <a:lstStyle/>
           <a:p>
-            <a:pPr algn="l">
-              <a:lnSpc>
-                <a:spcPct val="108000"/>
-              </a:lnSpc>
-              <a:spcAft>
-                <a:spcPts val="800"/>
-              </a:spcAft>
-            </a:pPr>
-            <a:r>
-              <a:rPr sz="1500" b="1">
+            <a:pPr algn="ctr">
+              <a:lnSpc>
+                <a:spcPct val="108000"/>
+              </a:lnSpc>
+              <a:spcAft>
+                <a:spcPts val="0"/>
+              </a:spcAft>
+            </a:pPr>
+            <a:r>
+              <a:rPr sz="1150" b="1">
                 <a:solidFill>
                   <a:srgbClr val="F2F7F6"/>
                 </a:solidFill>
-                <a:latin typeface="Consolas"/>
-              </a:rPr>
-              <a:t>artifacts</a:t>
-            </a:r>
-          </a:p>
-        </p:txBody>
-      </p:sp>
-      <p:sp>
-        <p:nvSpPr>
-          <p:cNvPr id="21" name="TextBox 20"/>
+                <a:latin typeface="Georgia"/>
+              </a:rPr>
+              <a:t>Oncologist</a:t>
+            </a:r>
+          </a:p>
+        </p:txBody>
+      </p:sp>
+      <p:sp>
+        <p:nvSpPr>
+          <p:cNvPr id="51" name="TextBox 50"/>
           <p:cNvSpPr txBox="1"/>
           <p:nvPr/>
         </p:nvSpPr>
         <p:spPr>
           <a:xfrm>
-            <a:off x="9683496" y="2852928"/>
-            <a:ext cx="1691640" cy="347472"/>
+            <a:off x="9902952" y="5010912"/>
+            <a:ext cx="1225296" cy="256032"/>
           </a:xfrm>
           <a:prstGeom prst="rect">
             <a:avLst/>
@@ -13919,36 +15179,221 @@
           </a:bodyPr>
           <a:lstStyle/>
           <a:p>
-            <a:pPr algn="l">
-              <a:lnSpc>
-                <a:spcPct val="108000"/>
-              </a:lnSpc>
-              <a:spcAft>
-                <a:spcPts val="800"/>
-              </a:spcAft>
-            </a:pPr>
-            <a:r>
-              <a:rPr sz="1100" b="0">
+            <a:pPr algn="ctr">
+              <a:lnSpc>
+                <a:spcPct val="108000"/>
+              </a:lnSpc>
+              <a:spcAft>
+                <a:spcPts val="0"/>
+              </a:spcAft>
+            </a:pPr>
+            <a:r>
+              <a:rPr sz="900" b="0">
                 <a:solidFill>
                   <a:srgbClr val="8CA3AD"/>
                 </a:solidFill>
                 <a:latin typeface="Consolas"/>
               </a:rPr>
-              <a:t>weights + metrics</a:t>
-            </a:r>
-          </a:p>
-        </p:txBody>
-      </p:sp>
-      <p:sp>
-        <p:nvSpPr>
-          <p:cNvPr id="22" name="TextBox 21"/>
+              <a:t>reads, decides</a:t>
+            </a:r>
+          </a:p>
+        </p:txBody>
+      </p:sp>
+      <p:cxnSp>
+        <p:nvCxnSpPr>
+          <p:cNvPr id="52" name="Connector 51"/>
+          <p:cNvCxnSpPr/>
+          <p:nvPr/>
+        </p:nvCxnSpPr>
+        <p:spPr>
+          <a:xfrm>
+            <a:off x="2148840" y="4937760"/>
+            <a:ext cx="576072" cy="0"/>
+          </a:xfrm>
+          <a:prstGeom prst="line">
+            <a:avLst/>
+          </a:prstGeom>
+          <a:ln w="22225">
+            <a:solidFill>
+              <a:srgbClr val="14B8A6"/>
+            </a:solidFill>
+            <a:tailEnd type="triangle" w="med" len="med"/>
+          </a:ln>
+          <a:effectLst/>
+        </p:spPr>
+        <p:style>
+          <a:lnRef idx="2">
+            <a:schemeClr val="accent1"/>
+          </a:lnRef>
+          <a:fillRef idx="0">
+            <a:schemeClr val="accent1"/>
+          </a:fillRef>
+          <a:effectRef idx="1">
+            <a:schemeClr val="accent1"/>
+          </a:effectRef>
+          <a:fontRef idx="minor">
+            <a:schemeClr val="tx1"/>
+          </a:fontRef>
+        </p:style>
+      </p:cxnSp>
+      <p:cxnSp>
+        <p:nvCxnSpPr>
+          <p:cNvPr id="53" name="Connector 52"/>
+          <p:cNvCxnSpPr/>
+          <p:nvPr/>
+        </p:nvCxnSpPr>
+        <p:spPr>
+          <a:xfrm>
+            <a:off x="3858768" y="4937760"/>
+            <a:ext cx="530352" cy="0"/>
+          </a:xfrm>
+          <a:prstGeom prst="line">
+            <a:avLst/>
+          </a:prstGeom>
+          <a:ln w="22225">
+            <a:solidFill>
+              <a:srgbClr val="14B8A6"/>
+            </a:solidFill>
+            <a:tailEnd type="triangle" w="med" len="med"/>
+          </a:ln>
+          <a:effectLst/>
+        </p:spPr>
+        <p:style>
+          <a:lnRef idx="2">
+            <a:schemeClr val="accent1"/>
+          </a:lnRef>
+          <a:fillRef idx="0">
+            <a:schemeClr val="accent1"/>
+          </a:fillRef>
+          <a:effectRef idx="1">
+            <a:schemeClr val="accent1"/>
+          </a:effectRef>
+          <a:fontRef idx="minor">
+            <a:schemeClr val="tx1"/>
+          </a:fontRef>
+        </p:style>
+      </p:cxnSp>
+      <p:cxnSp>
+        <p:nvCxnSpPr>
+          <p:cNvPr id="54" name="Connector 53"/>
+          <p:cNvCxnSpPr/>
+          <p:nvPr/>
+        </p:nvCxnSpPr>
+        <p:spPr>
+          <a:xfrm>
+            <a:off x="5522976" y="4937760"/>
+            <a:ext cx="530352" cy="0"/>
+          </a:xfrm>
+          <a:prstGeom prst="line">
+            <a:avLst/>
+          </a:prstGeom>
+          <a:ln w="22225">
+            <a:solidFill>
+              <a:srgbClr val="14B8A6"/>
+            </a:solidFill>
+            <a:tailEnd type="triangle" w="med" len="med"/>
+          </a:ln>
+          <a:effectLst/>
+        </p:spPr>
+        <p:style>
+          <a:lnRef idx="2">
+            <a:schemeClr val="accent1"/>
+          </a:lnRef>
+          <a:fillRef idx="0">
+            <a:schemeClr val="accent1"/>
+          </a:fillRef>
+          <a:effectRef idx="1">
+            <a:schemeClr val="accent1"/>
+          </a:effectRef>
+          <a:fontRef idx="minor">
+            <a:schemeClr val="tx1"/>
+          </a:fontRef>
+        </p:style>
+      </p:cxnSp>
+      <p:cxnSp>
+        <p:nvCxnSpPr>
+          <p:cNvPr id="55" name="Connector 54"/>
+          <p:cNvCxnSpPr/>
+          <p:nvPr/>
+        </p:nvCxnSpPr>
+        <p:spPr>
+          <a:xfrm>
+            <a:off x="7187184" y="4937760"/>
+            <a:ext cx="786384" cy="0"/>
+          </a:xfrm>
+          <a:prstGeom prst="line">
+            <a:avLst/>
+          </a:prstGeom>
+          <a:ln w="22225">
+            <a:solidFill>
+              <a:srgbClr val="14B8A6"/>
+            </a:solidFill>
+            <a:tailEnd type="triangle" w="med" len="med"/>
+          </a:ln>
+          <a:effectLst/>
+        </p:spPr>
+        <p:style>
+          <a:lnRef idx="2">
+            <a:schemeClr val="accent1"/>
+          </a:lnRef>
+          <a:fillRef idx="0">
+            <a:schemeClr val="accent1"/>
+          </a:fillRef>
+          <a:effectRef idx="1">
+            <a:schemeClr val="accent1"/>
+          </a:effectRef>
+          <a:fontRef idx="minor">
+            <a:schemeClr val="tx1"/>
+          </a:fontRef>
+        </p:style>
+      </p:cxnSp>
+      <p:cxnSp>
+        <p:nvCxnSpPr>
+          <p:cNvPr id="56" name="Connector 55"/>
+          <p:cNvCxnSpPr/>
+          <p:nvPr/>
+        </p:nvCxnSpPr>
+        <p:spPr>
+          <a:xfrm>
+            <a:off x="9400032" y="4937760"/>
+            <a:ext cx="402336" cy="0"/>
+          </a:xfrm>
+          <a:prstGeom prst="line">
+            <a:avLst/>
+          </a:prstGeom>
+          <a:ln w="22225">
+            <a:solidFill>
+              <a:srgbClr val="14B8A6"/>
+            </a:solidFill>
+            <a:tailEnd type="triangle" w="med" len="med"/>
+          </a:ln>
+          <a:effectLst/>
+        </p:spPr>
+        <p:style>
+          <a:lnRef idx="2">
+            <a:schemeClr val="accent1"/>
+          </a:lnRef>
+          <a:fillRef idx="0">
+            <a:schemeClr val="accent1"/>
+          </a:fillRef>
+          <a:effectRef idx="1">
+            <a:schemeClr val="accent1"/>
+          </a:effectRef>
+          <a:fontRef idx="minor">
+            <a:schemeClr val="tx1"/>
+          </a:fontRef>
+        </p:style>
+      </p:cxnSp>
+      <p:sp>
+        <p:nvSpPr>
+          <p:cNvPr id="57" name="TextBox 56"/>
           <p:cNvSpPr txBox="1"/>
           <p:nvPr/>
         </p:nvSpPr>
         <p:spPr>
           <a:xfrm>
-            <a:off x="2697480" y="2578608"/>
-            <a:ext cx="274320" cy="457200"/>
+            <a:off x="1938528" y="4636008"/>
+            <a:ext cx="1005840" cy="274320"/>
           </a:xfrm>
           <a:prstGeom prst="rect">
             <a:avLst/>
@@ -13966,31 +15411,31 @@
                 <a:spcPct val="108000"/>
               </a:lnSpc>
               <a:spcAft>
-                <a:spcPts val="800"/>
-              </a:spcAft>
-            </a:pPr>
-            <a:r>
-              <a:rPr sz="2600" b="0">
-                <a:solidFill>
-                  <a:srgbClr val="2DD4BF"/>
-                </a:solidFill>
-                <a:latin typeface="Georgia"/>
-              </a:rPr>
-              <a:t>›</a:t>
-            </a:r>
-          </a:p>
-        </p:txBody>
-      </p:sp>
-      <p:sp>
-        <p:nvSpPr>
-          <p:cNvPr id="23" name="TextBox 22"/>
+                <a:spcPts val="0"/>
+              </a:spcAft>
+            </a:pPr>
+            <a:r>
+              <a:rPr sz="900" b="0">
+                <a:solidFill>
+                  <a:srgbClr val="8CA3AD"/>
+                </a:solidFill>
+                <a:latin typeface="Consolas"/>
+              </a:rPr>
+              <a:t>report</a:t>
+            </a:r>
+          </a:p>
+        </p:txBody>
+      </p:sp>
+      <p:sp>
+        <p:nvSpPr>
+          <p:cNvPr id="58" name="TextBox 57"/>
           <p:cNvSpPr txBox="1"/>
           <p:nvPr/>
         </p:nvSpPr>
         <p:spPr>
           <a:xfrm>
-            <a:off x="4892040" y="2578608"/>
-            <a:ext cx="274320" cy="457200"/>
+            <a:off x="3621024" y="4636008"/>
+            <a:ext cx="1005840" cy="274320"/>
           </a:xfrm>
           <a:prstGeom prst="rect">
             <a:avLst/>
@@ -14008,31 +15453,31 @@
                 <a:spcPct val="108000"/>
               </a:lnSpc>
               <a:spcAft>
-                <a:spcPts val="800"/>
-              </a:spcAft>
-            </a:pPr>
-            <a:r>
-              <a:rPr sz="2600" b="0">
-                <a:solidFill>
-                  <a:srgbClr val="2DD4BF"/>
-                </a:solidFill>
-                <a:latin typeface="Georgia"/>
-              </a:rPr>
-              <a:t>›</a:t>
-            </a:r>
-          </a:p>
-        </p:txBody>
-      </p:sp>
-      <p:sp>
-        <p:nvSpPr>
-          <p:cNvPr id="24" name="TextBox 23"/>
+                <a:spcPts val="0"/>
+              </a:spcAft>
+            </a:pPr>
+            <a:r>
+              <a:rPr sz="900" b="0">
+                <a:solidFill>
+                  <a:srgbClr val="8CA3AD"/>
+                </a:solidFill>
+                <a:latin typeface="Consolas"/>
+              </a:rPr>
+              <a:t>signals</a:t>
+            </a:r>
+          </a:p>
+        </p:txBody>
+      </p:sp>
+      <p:sp>
+        <p:nvSpPr>
+          <p:cNvPr id="59" name="TextBox 58"/>
           <p:cNvSpPr txBox="1"/>
           <p:nvPr/>
         </p:nvSpPr>
         <p:spPr>
           <a:xfrm>
-            <a:off x="7086600" y="2578608"/>
-            <a:ext cx="274320" cy="457200"/>
+            <a:off x="5285232" y="4636008"/>
+            <a:ext cx="1005840" cy="274320"/>
           </a:xfrm>
           <a:prstGeom prst="rect">
             <a:avLst/>
@@ -14050,31 +15495,31 @@
                 <a:spcPct val="108000"/>
               </a:lnSpc>
               <a:spcAft>
-                <a:spcPts val="800"/>
-              </a:spcAft>
-            </a:pPr>
-            <a:r>
-              <a:rPr sz="2600" b="0">
-                <a:solidFill>
-                  <a:srgbClr val="2DD4BF"/>
-                </a:solidFill>
-                <a:latin typeface="Georgia"/>
-              </a:rPr>
-              <a:t>›</a:t>
-            </a:r>
-          </a:p>
-        </p:txBody>
-      </p:sp>
-      <p:sp>
-        <p:nvSpPr>
-          <p:cNvPr id="25" name="TextBox 24"/>
+                <a:spcPts val="0"/>
+              </a:spcAft>
+            </a:pPr>
+            <a:r>
+              <a:rPr sz="900" b="0">
+                <a:solidFill>
+                  <a:srgbClr val="8CA3AD"/>
+                </a:solidFill>
+                <a:latin typeface="Consolas"/>
+              </a:rPr>
+              <a:t>proba</a:t>
+            </a:r>
+          </a:p>
+        </p:txBody>
+      </p:sp>
+      <p:sp>
+        <p:nvSpPr>
+          <p:cNvPr id="60" name="TextBox 59"/>
           <p:cNvSpPr txBox="1"/>
           <p:nvPr/>
         </p:nvSpPr>
         <p:spPr>
           <a:xfrm>
-            <a:off x="9281160" y="2578608"/>
-            <a:ext cx="274320" cy="457200"/>
+            <a:off x="7077455" y="4636008"/>
+            <a:ext cx="1005840" cy="274320"/>
           </a:xfrm>
           <a:prstGeom prst="rect">
             <a:avLst/>
@@ -14092,31 +15537,31 @@
                 <a:spcPct val="108000"/>
               </a:lnSpc>
               <a:spcAft>
-                <a:spcPts val="800"/>
-              </a:spcAft>
-            </a:pPr>
-            <a:r>
-              <a:rPr sz="2600" b="0">
-                <a:solidFill>
-                  <a:srgbClr val="2DD4BF"/>
-                </a:solidFill>
-                <a:latin typeface="Georgia"/>
-              </a:rPr>
-              <a:t>›</a:t>
-            </a:r>
-          </a:p>
-        </p:txBody>
-      </p:sp>
-      <p:sp>
-        <p:nvSpPr>
-          <p:cNvPr id="26" name="TextBox 25"/>
+                <a:spcPts val="0"/>
+              </a:spcAft>
+            </a:pPr>
+            <a:r>
+              <a:rPr sz="900" b="0">
+                <a:solidFill>
+                  <a:srgbClr val="8CA3AD"/>
+                </a:solidFill>
+                <a:latin typeface="Consolas"/>
+              </a:rPr>
+              <a:t>matches</a:t>
+            </a:r>
+          </a:p>
+        </p:txBody>
+      </p:sp>
+      <p:sp>
+        <p:nvSpPr>
+          <p:cNvPr id="61" name="TextBox 60"/>
           <p:cNvSpPr txBox="1"/>
           <p:nvPr/>
         </p:nvSpPr>
         <p:spPr>
           <a:xfrm>
-            <a:off x="777240" y="3456432"/>
-            <a:ext cx="10698480" cy="365760"/>
+            <a:off x="9372600" y="4636008"/>
+            <a:ext cx="457200" cy="274320"/>
           </a:xfrm>
           <a:prstGeom prst="rect">
             <a:avLst/>
@@ -14134,75 +15579,107 @@
                 <a:spcPct val="108000"/>
               </a:lnSpc>
               <a:spcAft>
-                <a:spcPts val="800"/>
-              </a:spcAft>
-            </a:pPr>
-            <a:r>
-              <a:rPr sz="1300" b="0">
+                <a:spcPts val="0"/>
+              </a:spcAft>
+            </a:pPr>
+            <a:r>
+              <a:rPr sz="900" b="0">
                 <a:solidFill>
                   <a:srgbClr val="8CA3AD"/>
                 </a:solidFill>
                 <a:latin typeface="Consolas"/>
               </a:rPr>
-              <a:t>corpus + model artifact load once, at app start        ↓</a:t>
-            </a:r>
-          </a:p>
-        </p:txBody>
-      </p:sp>
-      <p:sp>
-        <p:nvSpPr>
-          <p:cNvPr id="27" name="Rectangle 26"/>
-          <p:cNvSpPr/>
-          <p:nvPr/>
-        </p:nvSpPr>
-        <p:spPr>
-          <a:xfrm>
-            <a:off x="822960" y="3941064"/>
-            <a:ext cx="109728" cy="109728"/>
-          </a:xfrm>
-          <a:prstGeom prst="rect">
-            <a:avLst/>
-          </a:prstGeom>
-          <a:solidFill>
-            <a:srgbClr val="14B8A6"/>
-          </a:solidFill>
-          <a:ln>
-            <a:noFill/>
+              <a:t>read</a:t>
+            </a:r>
+          </a:p>
+        </p:txBody>
+      </p:sp>
+      <p:cxnSp>
+        <p:nvCxnSpPr>
+          <p:cNvPr id="62" name="Connector 61"/>
+          <p:cNvCxnSpPr/>
+          <p:nvPr/>
+        </p:nvCxnSpPr>
+        <p:spPr>
+          <a:xfrm flipH="1">
+            <a:off x="5193792" y="3310128"/>
+            <a:ext cx="3447288" cy="1042416"/>
+          </a:xfrm>
+          <a:prstGeom prst="line">
+            <a:avLst/>
+          </a:prstGeom>
+          <a:ln w="19050">
+            <a:solidFill>
+              <a:srgbClr val="2DD4BF"/>
+            </a:solidFill>
+            <a:prstDash val="dash"/>
+            <a:tailEnd type="triangle" w="med" len="med"/>
           </a:ln>
           <a:effectLst/>
         </p:spPr>
         <p:style>
-          <a:lnRef idx="1">
+          <a:lnRef idx="2">
             <a:schemeClr val="accent1"/>
           </a:lnRef>
-          <a:fillRef idx="3">
+          <a:fillRef idx="0">
             <a:schemeClr val="accent1"/>
           </a:fillRef>
-          <a:effectRef idx="2">
+          <a:effectRef idx="1">
             <a:schemeClr val="accent1"/>
           </a:effectRef>
           <a:fontRef idx="minor">
-            <a:schemeClr val="lt1"/>
+            <a:schemeClr val="tx1"/>
           </a:fontRef>
         </p:style>
-        <p:txBody>
-          <a:bodyPr rtlCol="0" anchor="ctr"/>
-          <a:lstStyle/>
-          <a:p>
-            <a:pPr algn="ctr"/>
-          </a:p>
-        </p:txBody>
-      </p:sp>
-      <p:sp>
-        <p:nvSpPr>
-          <p:cNvPr id="28" name="TextBox 27"/>
+      </p:cxnSp>
+      <p:cxnSp>
+        <p:nvCxnSpPr>
+          <p:cNvPr id="63" name="Connector 62"/>
+          <p:cNvCxnSpPr/>
+          <p:nvPr/>
+        </p:nvCxnSpPr>
+        <p:spPr>
+          <a:xfrm>
+            <a:off x="5074920" y="3310128"/>
+            <a:ext cx="1325880" cy="1042416"/>
+          </a:xfrm>
+          <a:prstGeom prst="line">
+            <a:avLst/>
+          </a:prstGeom>
+          <a:ln w="19050">
+            <a:solidFill>
+              <a:srgbClr val="8CA3AD"/>
+            </a:solidFill>
+            <a:prstDash val="dash"/>
+            <a:tailEnd type="triangle" w="med" len="med"/>
+          </a:ln>
+          <a:effectLst/>
+        </p:spPr>
+        <p:style>
+          <a:lnRef idx="2">
+            <a:schemeClr val="accent1"/>
+          </a:lnRef>
+          <a:fillRef idx="0">
+            <a:schemeClr val="accent1"/>
+          </a:fillRef>
+          <a:effectRef idx="1">
+            <a:schemeClr val="accent1"/>
+          </a:effectRef>
+          <a:fontRef idx="minor">
+            <a:schemeClr val="tx1"/>
+          </a:fontRef>
+        </p:style>
+      </p:cxnSp>
+      <p:sp>
+        <p:nvSpPr>
+          <p:cNvPr id="64" name="TextBox 63"/>
           <p:cNvSpPr txBox="1"/>
           <p:nvPr/>
         </p:nvSpPr>
         <p:spPr>
           <a:xfrm>
-            <a:off x="1078992" y="3877056"/>
-            <a:ext cx="6400800" cy="365760"/>
+            <a:off x="7223759" y="3913632"/>
+            <a:ext cx="822960" cy="274320"/>
           </a:xfrm>
           <a:prstGeom prst="rect">
             <a:avLst/>
@@ -14215,41 +15692,81 @@
           </a:bodyPr>
           <a:lstStyle/>
           <a:p>
-            <a:pPr algn="l">
-              <a:lnSpc>
-                <a:spcPct val="108000"/>
-              </a:lnSpc>
-              <a:spcAft>
-                <a:spcPts val="800"/>
-              </a:spcAft>
-            </a:pPr>
-            <a:r>
-              <a:rPr sz="1300" b="1">
-                <a:solidFill>
-                  <a:srgbClr val="2DD4BF"/>
+            <a:pPr algn="ctr">
+              <a:lnSpc>
+                <a:spcPct val="108000"/>
+              </a:lnSpc>
+              <a:spcAft>
+                <a:spcPts val="0"/>
+              </a:spcAft>
+            </a:pPr>
+            <a:r>
+              <a:rPr sz="900" b="0">
+                <a:solidFill>
+                  <a:srgbClr val="8CA3AD"/>
                 </a:solidFill>
                 <a:latin typeface="Consolas"/>
               </a:rPr>
-              <a:t>RUNS ON EVERY PATIENT — THE LIVE APP</a:t>
-            </a:r>
-          </a:p>
-        </p:txBody>
-      </p:sp>
-      <p:sp>
-        <p:nvSpPr>
-          <p:cNvPr id="29" name="Rounded Rectangle 28"/>
+              <a:t>weights</a:t>
+            </a:r>
+          </a:p>
+        </p:txBody>
+      </p:sp>
+      <p:sp>
+        <p:nvSpPr>
+          <p:cNvPr id="65" name="TextBox 64"/>
+          <p:cNvSpPr txBox="1"/>
+          <p:nvPr/>
+        </p:nvSpPr>
+        <p:spPr>
+          <a:xfrm>
+            <a:off x="4846320" y="3913632"/>
+            <a:ext cx="822960" cy="274320"/>
+          </a:xfrm>
+          <a:prstGeom prst="rect">
+            <a:avLst/>
+          </a:prstGeom>
+          <a:noFill/>
+        </p:spPr>
+        <p:txBody>
+          <a:bodyPr wrap="square" anchor="t" lIns="0" rIns="0" tIns="0" bIns="0">
+            <a:spAutoFit/>
+          </a:bodyPr>
+          <a:lstStyle/>
+          <a:p>
+            <a:pPr algn="ctr">
+              <a:lnSpc>
+                <a:spcPct val="108000"/>
+              </a:lnSpc>
+              <a:spcAft>
+                <a:spcPts val="0"/>
+              </a:spcAft>
+            </a:pPr>
+            <a:r>
+              <a:rPr sz="900" b="0">
+                <a:solidFill>
+                  <a:srgbClr val="8CA3AD"/>
+                </a:solidFill>
+                <a:latin typeface="Consolas"/>
+              </a:rPr>
+              <a:t>corpus</a:t>
+            </a:r>
+          </a:p>
+        </p:txBody>
+      </p:sp>
+      <p:sp>
+        <p:nvSpPr>
+          <p:cNvPr id="66" name="Rectangle 65"/>
           <p:cNvSpPr/>
           <p:nvPr/>
         </p:nvSpPr>
         <p:spPr>
           <a:xfrm>
-            <a:off x="777240" y="4279392"/>
-            <a:ext cx="1901952" cy="896112"/>
-          </a:xfrm>
-          <a:prstGeom prst="roundRect">
-            <a:avLst>
-              <a:gd name="adj" fmla="val 5000"/>
-            </a:avLst>
+            <a:off x="7772400" y="5760720"/>
+            <a:ext cx="1920240" cy="502920"/>
+          </a:xfrm>
+          <a:prstGeom prst="rect">
+            <a:avLst/>
           </a:prstGeom>
           <a:solidFill>
             <a:srgbClr val="13202B"/>
@@ -14283,14 +15800,14 @@
       </p:sp>
       <p:sp>
         <p:nvSpPr>
-          <p:cNvPr id="30" name="TextBox 29"/>
+          <p:cNvPr id="67" name="TextBox 66"/>
           <p:cNvSpPr txBox="1"/>
           <p:nvPr/>
         </p:nvSpPr>
         <p:spPr>
           <a:xfrm>
-            <a:off x="905256" y="4398264"/>
-            <a:ext cx="1691640" cy="347472"/>
+            <a:off x="7772400" y="5797296"/>
+            <a:ext cx="1920240" cy="219456"/>
           </a:xfrm>
           <a:prstGeom prst="rect">
             <a:avLst/>
@@ -14303,36 +15820,36 @@
           </a:bodyPr>
           <a:lstStyle/>
           <a:p>
-            <a:pPr algn="l">
-              <a:lnSpc>
-                <a:spcPct val="108000"/>
-              </a:lnSpc>
-              <a:spcAft>
-                <a:spcPts val="800"/>
-              </a:spcAft>
-            </a:pPr>
-            <a:r>
-              <a:rPr sz="1500" b="1">
+            <a:pPr algn="ctr">
+              <a:lnSpc>
+                <a:spcPct val="108000"/>
+              </a:lnSpc>
+              <a:spcAft>
+                <a:spcPts val="0"/>
+              </a:spcAft>
+            </a:pPr>
+            <a:r>
+              <a:rPr sz="1100" b="1">
                 <a:solidFill>
                   <a:srgbClr val="F2F7F6"/>
                 </a:solidFill>
-                <a:latin typeface="Consolas"/>
-              </a:rPr>
-              <a:t>genomic report</a:t>
-            </a:r>
-          </a:p>
-        </p:txBody>
-      </p:sp>
-      <p:sp>
-        <p:nvSpPr>
-          <p:cNvPr id="31" name="TextBox 30"/>
+                <a:latin typeface="Georgia"/>
+              </a:rPr>
+              <a:t>ClinicalTrials.gov</a:t>
+            </a:r>
+          </a:p>
+        </p:txBody>
+      </p:sp>
+      <p:sp>
+        <p:nvSpPr>
+          <p:cNvPr id="68" name="TextBox 67"/>
           <p:cNvSpPr txBox="1"/>
           <p:nvPr/>
         </p:nvSpPr>
         <p:spPr>
           <a:xfrm>
-            <a:off x="905256" y="4773168"/>
-            <a:ext cx="1691640" cy="347472"/>
+            <a:off x="7772400" y="6035040"/>
+            <a:ext cx="1920240" cy="201168"/>
           </a:xfrm>
           <a:prstGeom prst="rect">
             <a:avLst/>
@@ -14345,41 +15862,164 @@
           </a:bodyPr>
           <a:lstStyle/>
           <a:p>
+            <a:pPr algn="ctr">
+              <a:lnSpc>
+                <a:spcPct val="108000"/>
+              </a:lnSpc>
+              <a:spcAft>
+                <a:spcPts val="0"/>
+              </a:spcAft>
+            </a:pPr>
+            <a:r>
+              <a:rPr sz="800" b="0">
+                <a:solidFill>
+                  <a:srgbClr val="8CA3AD"/>
+                </a:solidFill>
+                <a:latin typeface="Consolas"/>
+              </a:rPr>
+              <a:t>live trial search</a:t>
+            </a:r>
+          </a:p>
+        </p:txBody>
+      </p:sp>
+      <p:cxnSp>
+        <p:nvCxnSpPr>
+          <p:cNvPr id="69" name="Connector 68"/>
+          <p:cNvCxnSpPr/>
+          <p:nvPr/>
+        </p:nvCxnSpPr>
+        <p:spPr>
+          <a:xfrm flipH="1" flipV="1">
+            <a:off x="6967728" y="5504688"/>
+            <a:ext cx="1124712" cy="237744"/>
+          </a:xfrm>
+          <a:prstGeom prst="line">
+            <a:avLst/>
+          </a:prstGeom>
+          <a:ln w="22225">
+            <a:solidFill>
+              <a:srgbClr val="14B8A6"/>
+            </a:solidFill>
+            <a:tailEnd type="triangle" w="med" len="med"/>
+          </a:ln>
+          <a:effectLst/>
+        </p:spPr>
+        <p:style>
+          <a:lnRef idx="2">
+            <a:schemeClr val="accent1"/>
+          </a:lnRef>
+          <a:fillRef idx="0">
+            <a:schemeClr val="accent1"/>
+          </a:fillRef>
+          <a:effectRef idx="1">
+            <a:schemeClr val="accent1"/>
+          </a:effectRef>
+          <a:fontRef idx="minor">
+            <a:schemeClr val="tx1"/>
+          </a:fontRef>
+        </p:style>
+      </p:cxnSp>
+      <p:sp>
+        <p:nvSpPr>
+          <p:cNvPr id="70" name="Oval 69"/>
+          <p:cNvSpPr/>
+          <p:nvPr/>
+        </p:nvSpPr>
+        <p:spPr>
+          <a:xfrm>
+            <a:off x="777240" y="5989320"/>
+            <a:ext cx="182880" cy="182880"/>
+          </a:xfrm>
+          <a:prstGeom prst="ellipse">
+            <a:avLst/>
+          </a:prstGeom>
+          <a:solidFill>
+            <a:srgbClr val="14B8A6"/>
+          </a:solidFill>
+          <a:ln>
+            <a:solidFill>
+              <a:srgbClr val="14B8A6"/>
+            </a:solidFill>
+          </a:ln>
+          <a:effectLst/>
+        </p:spPr>
+        <p:style>
+          <a:lnRef idx="1">
+            <a:schemeClr val="accent1"/>
+          </a:lnRef>
+          <a:fillRef idx="3">
+            <a:schemeClr val="accent1"/>
+          </a:fillRef>
+          <a:effectRef idx="2">
+            <a:schemeClr val="accent1"/>
+          </a:effectRef>
+          <a:fontRef idx="minor">
+            <a:schemeClr val="lt1"/>
+          </a:fontRef>
+        </p:style>
+        <p:txBody>
+          <a:bodyPr rtlCol="0" anchor="ctr"/>
+          <a:lstStyle/>
+          <a:p>
+            <a:pPr algn="ctr"/>
+          </a:p>
+        </p:txBody>
+      </p:sp>
+      <p:sp>
+        <p:nvSpPr>
+          <p:cNvPr id="71" name="TextBox 70"/>
+          <p:cNvSpPr txBox="1"/>
+          <p:nvPr/>
+        </p:nvSpPr>
+        <p:spPr>
+          <a:xfrm>
+            <a:off x="1051560" y="5952744"/>
+            <a:ext cx="777240" cy="274320"/>
+          </a:xfrm>
+          <a:prstGeom prst="rect">
+            <a:avLst/>
+          </a:prstGeom>
+          <a:noFill/>
+        </p:spPr>
+        <p:txBody>
+          <a:bodyPr wrap="square" anchor="t" lIns="0" rIns="0" tIns="0" bIns="0">
+            <a:spAutoFit/>
+          </a:bodyPr>
+          <a:lstStyle/>
+          <a:p>
             <a:pPr algn="l">
               <a:lnSpc>
                 <a:spcPct val="108000"/>
               </a:lnSpc>
               <a:spcAft>
-                <a:spcPts val="800"/>
-              </a:spcAft>
-            </a:pPr>
-            <a:r>
-              <a:rPr sz="1100" b="0">
+                <a:spcPts val="0"/>
+              </a:spcAft>
+            </a:pPr>
+            <a:r>
+              <a:rPr sz="900" b="0">
                 <a:solidFill>
                   <a:srgbClr val="8CA3AD"/>
                 </a:solidFill>
                 <a:latin typeface="Consolas"/>
               </a:rPr>
-              <a:t>upload / worklist</a:t>
-            </a:r>
-          </a:p>
-        </p:txBody>
-      </p:sp>
-      <p:sp>
-        <p:nvSpPr>
-          <p:cNvPr id="32" name="Rounded Rectangle 31"/>
+              <a:t>process</a:t>
+            </a:r>
+          </a:p>
+        </p:txBody>
+      </p:sp>
+      <p:sp>
+        <p:nvSpPr>
+          <p:cNvPr id="72" name="Rectangle 71"/>
           <p:cNvSpPr/>
           <p:nvPr/>
         </p:nvSpPr>
         <p:spPr>
           <a:xfrm>
-            <a:off x="2971800" y="4279392"/>
-            <a:ext cx="1901952" cy="896112"/>
-          </a:xfrm>
-          <a:prstGeom prst="roundRect">
-            <a:avLst>
-              <a:gd name="adj" fmla="val 5000"/>
-            </a:avLst>
+            <a:off x="1920240" y="5989320"/>
+            <a:ext cx="182880" cy="182880"/>
+          </a:xfrm>
+          <a:prstGeom prst="rect">
+            <a:avLst/>
           </a:prstGeom>
           <a:solidFill>
             <a:srgbClr val="13202B"/>
@@ -14413,14 +16053,14 @@
       </p:sp>
       <p:sp>
         <p:nvSpPr>
-          <p:cNvPr id="33" name="TextBox 32"/>
+          <p:cNvPr id="73" name="TextBox 72"/>
           <p:cNvSpPr txBox="1"/>
           <p:nvPr/>
         </p:nvSpPr>
         <p:spPr>
           <a:xfrm>
-            <a:off x="3099816" y="4398264"/>
-            <a:ext cx="1691640" cy="347472"/>
+            <a:off x="2194560" y="5952744"/>
+            <a:ext cx="777240" cy="274320"/>
           </a:xfrm>
           <a:prstGeom prst="rect">
             <a:avLst/>
@@ -14438,84 +16078,42 @@
                 <a:spcPct val="108000"/>
               </a:lnSpc>
               <a:spcAft>
-                <a:spcPts val="800"/>
-              </a:spcAft>
-            </a:pPr>
-            <a:r>
-              <a:rPr sz="1500" b="1">
-                <a:solidFill>
-                  <a:srgbClr val="F2F7F6"/>
+                <a:spcPts val="0"/>
+              </a:spcAft>
+            </a:pPr>
+            <a:r>
+              <a:rPr sz="900" b="0">
+                <a:solidFill>
+                  <a:srgbClr val="8CA3AD"/>
                 </a:solidFill>
                 <a:latin typeface="Consolas"/>
               </a:rPr>
-              <a:t>features.py</a:t>
-            </a:r>
-          </a:p>
-        </p:txBody>
-      </p:sp>
-      <p:sp>
-        <p:nvSpPr>
-          <p:cNvPr id="34" name="TextBox 33"/>
-          <p:cNvSpPr txBox="1"/>
-          <p:nvPr/>
-        </p:nvSpPr>
-        <p:spPr>
-          <a:xfrm>
-            <a:off x="3099816" y="4773168"/>
-            <a:ext cx="1691640" cy="347472"/>
-          </a:xfrm>
-          <a:prstGeom prst="rect">
-            <a:avLst/>
-          </a:prstGeom>
-          <a:noFill/>
-        </p:spPr>
-        <p:txBody>
-          <a:bodyPr wrap="square" anchor="t" lIns="0" rIns="0" tIns="0" bIns="0">
-            <a:spAutoFit/>
-          </a:bodyPr>
-          <a:lstStyle/>
-          <a:p>
-            <a:pPr algn="l">
-              <a:lnSpc>
-                <a:spcPct val="108000"/>
-              </a:lnSpc>
-              <a:spcAft>
-                <a:spcPts val="800"/>
-              </a:spcAft>
-            </a:pPr>
-            <a:r>
-              <a:rPr sz="1100" b="0">
-                <a:solidFill>
-                  <a:srgbClr val="8CA3AD"/>
-                </a:solidFill>
-                <a:latin typeface="Consolas"/>
-              </a:rPr>
-              <a:t>same 201 signals</a:t>
-            </a:r>
-          </a:p>
-        </p:txBody>
-      </p:sp>
-      <p:sp>
-        <p:nvSpPr>
-          <p:cNvPr id="35" name="Rounded Rectangle 34"/>
+              <a:t>entity</a:t>
+            </a:r>
+          </a:p>
+        </p:txBody>
+      </p:sp>
+      <p:sp>
+        <p:nvSpPr>
+          <p:cNvPr id="74" name="Can 73"/>
           <p:cNvSpPr/>
           <p:nvPr/>
         </p:nvSpPr>
         <p:spPr>
           <a:xfrm>
-            <a:off x="5166360" y="4279392"/>
-            <a:ext cx="1901952" cy="896112"/>
-          </a:xfrm>
-          <a:prstGeom prst="roundRect">
-            <a:avLst>
-              <a:gd name="adj" fmla="val 5000"/>
-            </a:avLst>
+            <a:off x="3063240" y="5961888"/>
+            <a:ext cx="201168" cy="256032"/>
+          </a:xfrm>
+          <a:prstGeom prst="can">
+            <a:avLst/>
           </a:prstGeom>
           <a:solidFill>
             <a:srgbClr val="13202B"/>
           </a:solidFill>
           <a:ln>
-            <a:noFill/>
+            <a:solidFill>
+              <a:srgbClr val="14B8A6"/>
+            </a:solidFill>
           </a:ln>
           <a:effectLst/>
         </p:spPr>
@@ -14543,14 +16141,14 @@
       </p:sp>
       <p:sp>
         <p:nvSpPr>
-          <p:cNvPr id="36" name="TextBox 35"/>
+          <p:cNvPr id="75" name="TextBox 74"/>
           <p:cNvSpPr txBox="1"/>
           <p:nvPr/>
         </p:nvSpPr>
         <p:spPr>
           <a:xfrm>
-            <a:off x="5294376" y="4398264"/>
-            <a:ext cx="1691640" cy="347472"/>
+            <a:off x="3364992" y="5952744"/>
+            <a:ext cx="731520" cy="274320"/>
           </a:xfrm>
           <a:prstGeom prst="rect">
             <a:avLst/>
@@ -14568,31 +16166,68 @@
                 <a:spcPct val="108000"/>
               </a:lnSpc>
               <a:spcAft>
-                <a:spcPts val="800"/>
-              </a:spcAft>
-            </a:pPr>
-            <a:r>
-              <a:rPr sz="1500" b="1">
-                <a:solidFill>
-                  <a:srgbClr val="F2F7F6"/>
+                <a:spcPts val="0"/>
+              </a:spcAft>
+            </a:pPr>
+            <a:r>
+              <a:rPr sz="900" b="0">
+                <a:solidFill>
+                  <a:srgbClr val="8CA3AD"/>
                 </a:solidFill>
                 <a:latin typeface="Consolas"/>
               </a:rPr>
-              <a:t>predictor.py</a:t>
-            </a:r>
-          </a:p>
-        </p:txBody>
-      </p:sp>
-      <p:sp>
-        <p:nvSpPr>
-          <p:cNvPr id="37" name="TextBox 36"/>
+              <a:t>store</a:t>
+            </a:r>
+          </a:p>
+        </p:txBody>
+      </p:sp>
+      <p:cxnSp>
+        <p:nvCxnSpPr>
+          <p:cNvPr id="76" name="Connector 75"/>
+          <p:cNvCxnSpPr/>
+          <p:nvPr/>
+        </p:nvCxnSpPr>
+        <p:spPr>
+          <a:xfrm>
+            <a:off x="4206240" y="6080759"/>
+            <a:ext cx="347472" cy="0"/>
+          </a:xfrm>
+          <a:prstGeom prst="line">
+            <a:avLst/>
+          </a:prstGeom>
+          <a:ln w="22225">
+            <a:solidFill>
+              <a:srgbClr val="14B8A6"/>
+            </a:solidFill>
+            <a:tailEnd type="triangle" w="med" len="med"/>
+          </a:ln>
+          <a:effectLst/>
+        </p:spPr>
+        <p:style>
+          <a:lnRef idx="2">
+            <a:schemeClr val="accent1"/>
+          </a:lnRef>
+          <a:fillRef idx="0">
+            <a:schemeClr val="accent1"/>
+          </a:fillRef>
+          <a:effectRef idx="1">
+            <a:schemeClr val="accent1"/>
+          </a:effectRef>
+          <a:fontRef idx="minor">
+            <a:schemeClr val="tx1"/>
+          </a:fontRef>
+        </p:style>
+      </p:cxnSp>
+      <p:sp>
+        <p:nvSpPr>
+          <p:cNvPr id="77" name="TextBox 76"/>
           <p:cNvSpPr txBox="1"/>
           <p:nvPr/>
         </p:nvSpPr>
         <p:spPr>
           <a:xfrm>
-            <a:off x="5294376" y="4773168"/>
-            <a:ext cx="1691640" cy="347472"/>
+            <a:off x="4645152" y="5952744"/>
+            <a:ext cx="914400" cy="274320"/>
           </a:xfrm>
           <a:prstGeom prst="rect">
             <a:avLst/>
@@ -14610,77 +16245,69 @@
                 <a:spcPct val="108000"/>
               </a:lnSpc>
               <a:spcAft>
-                <a:spcPts val="800"/>
-              </a:spcAft>
-            </a:pPr>
-            <a:r>
-              <a:rPr sz="1100" b="0">
+                <a:spcPts val="0"/>
+              </a:spcAft>
+            </a:pPr>
+            <a:r>
+              <a:rPr sz="900" b="0">
                 <a:solidFill>
                   <a:srgbClr val="8CA3AD"/>
                 </a:solidFill>
                 <a:latin typeface="Consolas"/>
               </a:rPr>
-              <a:t>score · band · why</a:t>
-            </a:r>
-          </a:p>
-        </p:txBody>
-      </p:sp>
-      <p:sp>
-        <p:nvSpPr>
-          <p:cNvPr id="38" name="Rounded Rectangle 37"/>
-          <p:cNvSpPr/>
-          <p:nvPr/>
-        </p:nvSpPr>
-        <p:spPr>
-          <a:xfrm>
-            <a:off x="7360920" y="4279392"/>
-            <a:ext cx="1901952" cy="896112"/>
-          </a:xfrm>
-          <a:prstGeom prst="roundRect">
-            <a:avLst>
-              <a:gd name="adj" fmla="val 5000"/>
-            </a:avLst>
-          </a:prstGeom>
-          <a:solidFill>
-            <a:srgbClr val="13202B"/>
-          </a:solidFill>
-          <a:ln>
-            <a:noFill/>
+              <a:t>data flow</a:t>
+            </a:r>
+          </a:p>
+        </p:txBody>
+      </p:sp>
+      <p:cxnSp>
+        <p:nvCxnSpPr>
+          <p:cNvPr id="78" name="Connector 77"/>
+          <p:cNvCxnSpPr/>
+          <p:nvPr/>
+        </p:nvCxnSpPr>
+        <p:spPr>
+          <a:xfrm>
+            <a:off x="5623560" y="6080759"/>
+            <a:ext cx="347472" cy="0"/>
+          </a:xfrm>
+          <a:prstGeom prst="line">
+            <a:avLst/>
+          </a:prstGeom>
+          <a:ln w="19050">
+            <a:solidFill>
+              <a:srgbClr val="8CA3AD"/>
+            </a:solidFill>
+            <a:prstDash val="dash"/>
+            <a:tailEnd type="triangle" w="med" len="med"/>
           </a:ln>
           <a:effectLst/>
         </p:spPr>
         <p:style>
-          <a:lnRef idx="1">
+          <a:lnRef idx="2">
             <a:schemeClr val="accent1"/>
           </a:lnRef>
-          <a:fillRef idx="3">
+          <a:fillRef idx="0">
             <a:schemeClr val="accent1"/>
           </a:fillRef>
-          <a:effectRef idx="2">
+          <a:effectRef idx="1">
             <a:schemeClr val="accent1"/>
           </a:effectRef>
           <a:fontRef idx="minor">
-            <a:schemeClr val="lt1"/>
+            <a:schemeClr val="tx1"/>
           </a:fontRef>
         </p:style>
-        <p:txBody>
-          <a:bodyPr rtlCol="0" anchor="ctr"/>
-          <a:lstStyle/>
-          <a:p>
-            <a:pPr algn="ctr"/>
-          </a:p>
-        </p:txBody>
-      </p:sp>
-      <p:sp>
-        <p:nvSpPr>
-          <p:cNvPr id="39" name="TextBox 38"/>
+      </p:cxnSp>
+      <p:sp>
+        <p:nvSpPr>
+          <p:cNvPr id="79" name="TextBox 78"/>
           <p:cNvSpPr txBox="1"/>
           <p:nvPr/>
         </p:nvSpPr>
         <p:spPr>
           <a:xfrm>
-            <a:off x="7488936" y="4398264"/>
-            <a:ext cx="1691640" cy="347472"/>
+            <a:off x="6062472" y="5952744"/>
+            <a:ext cx="1280160" cy="274320"/>
           </a:xfrm>
           <a:prstGeom prst="rect">
             <a:avLst/>
@@ -14698,619 +16325,17 @@
                 <a:spcPct val="108000"/>
               </a:lnSpc>
               <a:spcAft>
-                <a:spcPts val="800"/>
-              </a:spcAft>
-            </a:pPr>
-            <a:r>
-              <a:rPr sz="1500" b="1">
-                <a:solidFill>
-                  <a:srgbClr val="F2F7F6"/>
+                <a:spcPts val="0"/>
+              </a:spcAft>
+            </a:pPr>
+            <a:r>
+              <a:rPr sz="900" b="0">
+                <a:solidFill>
+                  <a:srgbClr val="8CA3AD"/>
                 </a:solidFill>
                 <a:latin typeface="Consolas"/>
               </a:rPr>
-              <a:t>engines</a:t>
-            </a:r>
-          </a:p>
-        </p:txBody>
-      </p:sp>
-      <p:sp>
-        <p:nvSpPr>
-          <p:cNvPr id="40" name="TextBox 39"/>
-          <p:cNvSpPr txBox="1"/>
-          <p:nvPr/>
-        </p:nvSpPr>
-        <p:spPr>
-          <a:xfrm>
-            <a:off x="7488936" y="4773168"/>
-            <a:ext cx="1691640" cy="347472"/>
-          </a:xfrm>
-          <a:prstGeom prst="rect">
-            <a:avLst/>
-          </a:prstGeom>
-          <a:noFill/>
-        </p:spPr>
-        <p:txBody>
-          <a:bodyPr wrap="square" anchor="t" lIns="0" rIns="0" tIns="0" bIns="0">
-            <a:spAutoFit/>
-          </a:bodyPr>
-          <a:lstStyle/>
-          <a:p>
-            <a:pPr algn="l">
-              <a:lnSpc>
-                <a:spcPct val="108000"/>
-              </a:lnSpc>
-              <a:spcAft>
-                <a:spcPts val="800"/>
-              </a:spcAft>
-            </a:pPr>
-            <a:r>
-              <a:rPr sz="1100" b="0">
-                <a:solidFill>
-                  <a:srgbClr val="8CA3AD"/>
-                </a:solidFill>
-                <a:latin typeface="Consolas"/>
-              </a:rPr>
-              <a:t>twins · cohorts</a:t>
-            </a:r>
-          </a:p>
-        </p:txBody>
-      </p:sp>
-      <p:sp>
-        <p:nvSpPr>
-          <p:cNvPr id="41" name="Rounded Rectangle 40"/>
-          <p:cNvSpPr/>
-          <p:nvPr/>
-        </p:nvSpPr>
-        <p:spPr>
-          <a:xfrm>
-            <a:off x="9555480" y="4279392"/>
-            <a:ext cx="1901952" cy="896112"/>
-          </a:xfrm>
-          <a:prstGeom prst="roundRect">
-            <a:avLst>
-              <a:gd name="adj" fmla="val 5000"/>
-            </a:avLst>
-          </a:prstGeom>
-          <a:solidFill>
-            <a:srgbClr val="13202B"/>
-          </a:solidFill>
-          <a:ln>
-            <a:noFill/>
-          </a:ln>
-          <a:effectLst/>
-        </p:spPr>
-        <p:style>
-          <a:lnRef idx="1">
-            <a:schemeClr val="accent1"/>
-          </a:lnRef>
-          <a:fillRef idx="3">
-            <a:schemeClr val="accent1"/>
-          </a:fillRef>
-          <a:effectRef idx="2">
-            <a:schemeClr val="accent1"/>
-          </a:effectRef>
-          <a:fontRef idx="minor">
-            <a:schemeClr val="lt1"/>
-          </a:fontRef>
-        </p:style>
-        <p:txBody>
-          <a:bodyPr rtlCol="0" anchor="ctr"/>
-          <a:lstStyle/>
-          <a:p>
-            <a:pPr algn="ctr"/>
-          </a:p>
-        </p:txBody>
-      </p:sp>
-      <p:sp>
-        <p:nvSpPr>
-          <p:cNvPr id="42" name="TextBox 41"/>
-          <p:cNvSpPr txBox="1"/>
-          <p:nvPr/>
-        </p:nvSpPr>
-        <p:spPr>
-          <a:xfrm>
-            <a:off x="9683496" y="4398264"/>
-            <a:ext cx="1691640" cy="347472"/>
-          </a:xfrm>
-          <a:prstGeom prst="rect">
-            <a:avLst/>
-          </a:prstGeom>
-          <a:noFill/>
-        </p:spPr>
-        <p:txBody>
-          <a:bodyPr wrap="square" anchor="t" lIns="0" rIns="0" tIns="0" bIns="0">
-            <a:spAutoFit/>
-          </a:bodyPr>
-          <a:lstStyle/>
-          <a:p>
-            <a:pPr algn="l">
-              <a:lnSpc>
-                <a:spcPct val="108000"/>
-              </a:lnSpc>
-              <a:spcAft>
-                <a:spcPts val="800"/>
-              </a:spcAft>
-            </a:pPr>
-            <a:r>
-              <a:rPr sz="1500" b="1">
-                <a:solidFill>
-                  <a:srgbClr val="F2F7F6"/>
-                </a:solidFill>
-                <a:latin typeface="Consolas"/>
-              </a:rPr>
-              <a:t>app.py + API</a:t>
-            </a:r>
-          </a:p>
-        </p:txBody>
-      </p:sp>
-      <p:sp>
-        <p:nvSpPr>
-          <p:cNvPr id="43" name="TextBox 42"/>
-          <p:cNvSpPr txBox="1"/>
-          <p:nvPr/>
-        </p:nvSpPr>
-        <p:spPr>
-          <a:xfrm>
-            <a:off x="9683496" y="4773168"/>
-            <a:ext cx="1691640" cy="347472"/>
-          </a:xfrm>
-          <a:prstGeom prst="rect">
-            <a:avLst/>
-          </a:prstGeom>
-          <a:noFill/>
-        </p:spPr>
-        <p:txBody>
-          <a:bodyPr wrap="square" anchor="t" lIns="0" rIns="0" tIns="0" bIns="0">
-            <a:spAutoFit/>
-          </a:bodyPr>
-          <a:lstStyle/>
-          <a:p>
-            <a:pPr algn="l">
-              <a:lnSpc>
-                <a:spcPct val="108000"/>
-              </a:lnSpc>
-              <a:spcAft>
-                <a:spcPts val="800"/>
-              </a:spcAft>
-            </a:pPr>
-            <a:r>
-              <a:rPr sz="1100" b="0">
-                <a:solidFill>
-                  <a:srgbClr val="8CA3AD"/>
-                </a:solidFill>
-                <a:latin typeface="Consolas"/>
-              </a:rPr>
-              <a:t>Streamlit · Flask</a:t>
-            </a:r>
-          </a:p>
-        </p:txBody>
-      </p:sp>
-      <p:sp>
-        <p:nvSpPr>
-          <p:cNvPr id="44" name="TextBox 43"/>
-          <p:cNvSpPr txBox="1"/>
-          <p:nvPr/>
-        </p:nvSpPr>
-        <p:spPr>
-          <a:xfrm>
-            <a:off x="2697480" y="4498848"/>
-            <a:ext cx="274320" cy="457200"/>
-          </a:xfrm>
-          <a:prstGeom prst="rect">
-            <a:avLst/>
-          </a:prstGeom>
-          <a:noFill/>
-        </p:spPr>
-        <p:txBody>
-          <a:bodyPr wrap="square" anchor="t" lIns="0" rIns="0" tIns="0" bIns="0">
-            <a:spAutoFit/>
-          </a:bodyPr>
-          <a:lstStyle/>
-          <a:p>
-            <a:pPr algn="ctr">
-              <a:lnSpc>
-                <a:spcPct val="108000"/>
-              </a:lnSpc>
-              <a:spcAft>
-                <a:spcPts val="800"/>
-              </a:spcAft>
-            </a:pPr>
-            <a:r>
-              <a:rPr sz="2600" b="0">
-                <a:solidFill>
-                  <a:srgbClr val="2DD4BF"/>
-                </a:solidFill>
-                <a:latin typeface="Georgia"/>
-              </a:rPr>
-              <a:t>›</a:t>
-            </a:r>
-          </a:p>
-        </p:txBody>
-      </p:sp>
-      <p:sp>
-        <p:nvSpPr>
-          <p:cNvPr id="45" name="TextBox 44"/>
-          <p:cNvSpPr txBox="1"/>
-          <p:nvPr/>
-        </p:nvSpPr>
-        <p:spPr>
-          <a:xfrm>
-            <a:off x="4892040" y="4498848"/>
-            <a:ext cx="274320" cy="457200"/>
-          </a:xfrm>
-          <a:prstGeom prst="rect">
-            <a:avLst/>
-          </a:prstGeom>
-          <a:noFill/>
-        </p:spPr>
-        <p:txBody>
-          <a:bodyPr wrap="square" anchor="t" lIns="0" rIns="0" tIns="0" bIns="0">
-            <a:spAutoFit/>
-          </a:bodyPr>
-          <a:lstStyle/>
-          <a:p>
-            <a:pPr algn="ctr">
-              <a:lnSpc>
-                <a:spcPct val="108000"/>
-              </a:lnSpc>
-              <a:spcAft>
-                <a:spcPts val="800"/>
-              </a:spcAft>
-            </a:pPr>
-            <a:r>
-              <a:rPr sz="2600" b="0">
-                <a:solidFill>
-                  <a:srgbClr val="2DD4BF"/>
-                </a:solidFill>
-                <a:latin typeface="Georgia"/>
-              </a:rPr>
-              <a:t>›</a:t>
-            </a:r>
-          </a:p>
-        </p:txBody>
-      </p:sp>
-      <p:sp>
-        <p:nvSpPr>
-          <p:cNvPr id="46" name="TextBox 45"/>
-          <p:cNvSpPr txBox="1"/>
-          <p:nvPr/>
-        </p:nvSpPr>
-        <p:spPr>
-          <a:xfrm>
-            <a:off x="7086600" y="4498848"/>
-            <a:ext cx="274320" cy="457200"/>
-          </a:xfrm>
-          <a:prstGeom prst="rect">
-            <a:avLst/>
-          </a:prstGeom>
-          <a:noFill/>
-        </p:spPr>
-        <p:txBody>
-          <a:bodyPr wrap="square" anchor="t" lIns="0" rIns="0" tIns="0" bIns="0">
-            <a:spAutoFit/>
-          </a:bodyPr>
-          <a:lstStyle/>
-          <a:p>
-            <a:pPr algn="ctr">
-              <a:lnSpc>
-                <a:spcPct val="108000"/>
-              </a:lnSpc>
-              <a:spcAft>
-                <a:spcPts val="800"/>
-              </a:spcAft>
-            </a:pPr>
-            <a:r>
-              <a:rPr sz="2600" b="0">
-                <a:solidFill>
-                  <a:srgbClr val="2DD4BF"/>
-                </a:solidFill>
-                <a:latin typeface="Georgia"/>
-              </a:rPr>
-              <a:t>›</a:t>
-            </a:r>
-          </a:p>
-        </p:txBody>
-      </p:sp>
-      <p:sp>
-        <p:nvSpPr>
-          <p:cNvPr id="47" name="TextBox 46"/>
-          <p:cNvSpPr txBox="1"/>
-          <p:nvPr/>
-        </p:nvSpPr>
-        <p:spPr>
-          <a:xfrm>
-            <a:off x="9281160" y="4498848"/>
-            <a:ext cx="274320" cy="457200"/>
-          </a:xfrm>
-          <a:prstGeom prst="rect">
-            <a:avLst/>
-          </a:prstGeom>
-          <a:noFill/>
-        </p:spPr>
-        <p:txBody>
-          <a:bodyPr wrap="square" anchor="t" lIns="0" rIns="0" tIns="0" bIns="0">
-            <a:spAutoFit/>
-          </a:bodyPr>
-          <a:lstStyle/>
-          <a:p>
-            <a:pPr algn="ctr">
-              <a:lnSpc>
-                <a:spcPct val="108000"/>
-              </a:lnSpc>
-              <a:spcAft>
-                <a:spcPts val="800"/>
-              </a:spcAft>
-            </a:pPr>
-            <a:r>
-              <a:rPr sz="2600" b="0">
-                <a:solidFill>
-                  <a:srgbClr val="2DD4BF"/>
-                </a:solidFill>
-                <a:latin typeface="Georgia"/>
-              </a:rPr>
-              <a:t>›</a:t>
-            </a:r>
-          </a:p>
-        </p:txBody>
-      </p:sp>
-      <p:sp>
-        <p:nvSpPr>
-          <p:cNvPr id="48" name="Rectangle 47"/>
-          <p:cNvSpPr/>
-          <p:nvPr/>
-        </p:nvSpPr>
-        <p:spPr>
-          <a:xfrm>
-            <a:off x="822960" y="5477256"/>
-            <a:ext cx="109728" cy="109728"/>
-          </a:xfrm>
-          <a:prstGeom prst="rect">
-            <a:avLst/>
-          </a:prstGeom>
-          <a:solidFill>
-            <a:srgbClr val="14B8A6"/>
-          </a:solidFill>
-          <a:ln>
-            <a:noFill/>
-          </a:ln>
-          <a:effectLst/>
-        </p:spPr>
-        <p:style>
-          <a:lnRef idx="1">
-            <a:schemeClr val="accent1"/>
-          </a:lnRef>
-          <a:fillRef idx="3">
-            <a:schemeClr val="accent1"/>
-          </a:fillRef>
-          <a:effectRef idx="2">
-            <a:schemeClr val="accent1"/>
-          </a:effectRef>
-          <a:fontRef idx="minor">
-            <a:schemeClr val="lt1"/>
-          </a:fontRef>
-        </p:style>
-        <p:txBody>
-          <a:bodyPr rtlCol="0" anchor="ctr"/>
-          <a:lstStyle/>
-          <a:p>
-            <a:pPr algn="ctr"/>
-          </a:p>
-        </p:txBody>
-      </p:sp>
-      <p:sp>
-        <p:nvSpPr>
-          <p:cNvPr id="49" name="TextBox 48"/>
-          <p:cNvSpPr txBox="1"/>
-          <p:nvPr/>
-        </p:nvSpPr>
-        <p:spPr>
-          <a:xfrm>
-            <a:off x="1078992" y="5413248"/>
-            <a:ext cx="6400800" cy="365760"/>
-          </a:xfrm>
-          <a:prstGeom prst="rect">
-            <a:avLst/>
-          </a:prstGeom>
-          <a:noFill/>
-        </p:spPr>
-        <p:txBody>
-          <a:bodyPr wrap="square" anchor="t" lIns="0" rIns="0" tIns="0" bIns="0">
-            <a:spAutoFit/>
-          </a:bodyPr>
-          <a:lstStyle/>
-          <a:p>
-            <a:pPr algn="l">
-              <a:lnSpc>
-                <a:spcPct val="108000"/>
-              </a:lnSpc>
-              <a:spcAft>
-                <a:spcPts val="800"/>
-              </a:spcAft>
-            </a:pPr>
-            <a:r>
-              <a:rPr sz="1300" b="1">
-                <a:solidFill>
-                  <a:srgbClr val="2DD4BF"/>
-                </a:solidFill>
-                <a:latin typeface="Consolas"/>
-              </a:rPr>
-              <a:t>SERVICES IT TALKS TO</a:t>
-            </a:r>
-          </a:p>
-        </p:txBody>
-      </p:sp>
-      <p:sp>
-        <p:nvSpPr>
-          <p:cNvPr id="50" name="Rounded Rectangle 49"/>
-          <p:cNvSpPr/>
-          <p:nvPr/>
-        </p:nvSpPr>
-        <p:spPr>
-          <a:xfrm>
-            <a:off x="777240" y="5797296"/>
-            <a:ext cx="5212080" cy="548640"/>
-          </a:xfrm>
-          <a:prstGeom prst="roundRect">
-            <a:avLst>
-              <a:gd name="adj" fmla="val 5000"/>
-            </a:avLst>
-          </a:prstGeom>
-          <a:solidFill>
-            <a:srgbClr val="13202B"/>
-          </a:solidFill>
-          <a:ln>
-            <a:noFill/>
-          </a:ln>
-          <a:effectLst/>
-        </p:spPr>
-        <p:style>
-          <a:lnRef idx="1">
-            <a:schemeClr val="accent1"/>
-          </a:lnRef>
-          <a:fillRef idx="3">
-            <a:schemeClr val="accent1"/>
-          </a:fillRef>
-          <a:effectRef idx="2">
-            <a:schemeClr val="accent1"/>
-          </a:effectRef>
-          <a:fontRef idx="minor">
-            <a:schemeClr val="lt1"/>
-          </a:fontRef>
-        </p:style>
-        <p:txBody>
-          <a:bodyPr rtlCol="0" anchor="ctr"/>
-          <a:lstStyle/>
-          <a:p>
-            <a:pPr algn="ctr"/>
-          </a:p>
-        </p:txBody>
-      </p:sp>
-      <p:sp>
-        <p:nvSpPr>
-          <p:cNvPr id="51" name="TextBox 50"/>
-          <p:cNvSpPr txBox="1"/>
-          <p:nvPr/>
-        </p:nvSpPr>
-        <p:spPr>
-          <a:xfrm>
-            <a:off x="1005840" y="5916168"/>
-            <a:ext cx="4846320" cy="320040"/>
-          </a:xfrm>
-          <a:prstGeom prst="rect">
-            <a:avLst/>
-          </a:prstGeom>
-          <a:noFill/>
-        </p:spPr>
-        <p:txBody>
-          <a:bodyPr wrap="square" anchor="t" lIns="0" rIns="0" tIns="0" bIns="0">
-            <a:spAutoFit/>
-          </a:bodyPr>
-          <a:lstStyle/>
-          <a:p>
-            <a:pPr algn="l">
-              <a:lnSpc>
-                <a:spcPct val="108000"/>
-              </a:lnSpc>
-              <a:spcAft>
-                <a:spcPts val="800"/>
-              </a:spcAft>
-            </a:pPr>
-            <a:r>
-              <a:rPr sz="1400" b="0">
-                <a:solidFill>
-                  <a:srgbClr val="8CA3AD"/>
-                </a:solidFill>
-                <a:latin typeface="Consolas"/>
-              </a:rPr>
-              <a:t>ClinicalTrials.gov — live trial search</a:t>
-            </a:r>
-          </a:p>
-        </p:txBody>
-      </p:sp>
-      <p:sp>
-        <p:nvSpPr>
-          <p:cNvPr id="52" name="Rounded Rectangle 51"/>
-          <p:cNvSpPr/>
-          <p:nvPr/>
-        </p:nvSpPr>
-        <p:spPr>
-          <a:xfrm>
-            <a:off x="6217920" y="5797296"/>
-            <a:ext cx="5212080" cy="548640"/>
-          </a:xfrm>
-          <a:prstGeom prst="roundRect">
-            <a:avLst>
-              <a:gd name="adj" fmla="val 5000"/>
-            </a:avLst>
-          </a:prstGeom>
-          <a:solidFill>
-            <a:srgbClr val="13202B"/>
-          </a:solidFill>
-          <a:ln>
-            <a:noFill/>
-          </a:ln>
-          <a:effectLst/>
-        </p:spPr>
-        <p:style>
-          <a:lnRef idx="1">
-            <a:schemeClr val="accent1"/>
-          </a:lnRef>
-          <a:fillRef idx="3">
-            <a:schemeClr val="accent1"/>
-          </a:fillRef>
-          <a:effectRef idx="2">
-            <a:schemeClr val="accent1"/>
-          </a:effectRef>
-          <a:fontRef idx="minor">
-            <a:schemeClr val="lt1"/>
-          </a:fontRef>
-        </p:style>
-        <p:txBody>
-          <a:bodyPr rtlCol="0" anchor="ctr"/>
-          <a:lstStyle/>
-          <a:p>
-            <a:pPr algn="ctr"/>
-          </a:p>
-        </p:txBody>
-      </p:sp>
-      <p:sp>
-        <p:nvSpPr>
-          <p:cNvPr id="53" name="TextBox 52"/>
-          <p:cNvSpPr txBox="1"/>
-          <p:nvPr/>
-        </p:nvSpPr>
-        <p:spPr>
-          <a:xfrm>
-            <a:off x="6446520" y="5916168"/>
-            <a:ext cx="4846320" cy="320040"/>
-          </a:xfrm>
-          <a:prstGeom prst="rect">
-            <a:avLst/>
-          </a:prstGeom>
-          <a:noFill/>
-        </p:spPr>
-        <p:txBody>
-          <a:bodyPr wrap="square" anchor="t" lIns="0" rIns="0" tIns="0" bIns="0">
-            <a:spAutoFit/>
-          </a:bodyPr>
-          <a:lstStyle/>
-          <a:p>
-            <a:pPr algn="l">
-              <a:lnSpc>
-                <a:spcPct val="108000"/>
-              </a:lnSpc>
-              <a:spcAft>
-                <a:spcPts val="800"/>
-              </a:spcAft>
-            </a:pPr>
-            <a:r>
-              <a:rPr sz="1400" b="0">
-                <a:solidFill>
-                  <a:srgbClr val="8CA3AD"/>
-                </a:solidFill>
-                <a:latin typeface="Consolas"/>
-              </a:rPr>
-              <a:t>cBioPortal — source of the training data</a:t>
+              <a:t>load / fetch</a:t>
             </a:r>
           </a:p>
         </p:txBody>

</xml_diff>

<commit_message>
Point demo links at theresistanceaiproject.streamlit.app
New Streamlit Cloud deployment under dev-abhinavmishra, backed by the
private resistanceai-deploy bundle (model artifact + licensed corpus).
Slide 5/13 display text resized for the longer domain; button widened.

Generated with [Devin](https://devin.ai)

Co-Authored-By: Devin <158243242+devin-ai-integration[bot]@users.noreply.github.com>
</commit_message>
<xml_diff>
--- a/ResistanceAI_Presentation_v9.pptx
+++ b/ResistanceAI_Presentation_v9.pptx
@@ -795,7 +795,7 @@
           <a:lstStyle/>
           <a:p>
             <a:r>
-              <a:t>That is ResistanceAI. It gives a doctor the kind of read an expert panel would give, in seconds, with the reasoning left on the screen. Everything you saw is the running app on real public data, and the button on screen opens the public demo at resistanceai.streamlit.app. Thanks for watching.</a:t>
+              <a:t>That is ResistanceAI. It gives a doctor the kind of read an expert panel would give, in seconds, with the reasoning left on the screen. Everything you saw is the running app on real public data, and the button on screen opens the public demo at theresistanceaiproject.streamlit.app. Thanks for watching.</a:t>
             </a:r>
           </a:p>
         </p:txBody>
@@ -4821,7 +4821,7 @@
                 <a:latin typeface="Consolas"/>
                 <a:hlinkClick r:id="rId2"/>
               </a:rPr>
-              <a:t>Open the live demo  ›  resistanceai.streamlit.app</a:t>
+              <a:t>Open the live demo  ›  theresistanceaiproject.streamlit.app</a:t>
             </a:r>
           </a:p>
         </p:txBody>
@@ -7301,7 +7301,7 @@
         <p:spPr>
           <a:xfrm>
             <a:off x="713232" y="5120640"/>
-            <a:ext cx="4114800" cy="777240"/>
+            <a:ext cx="4937760" cy="777240"/>
           </a:xfrm>
           <a:prstGeom prst="roundRect">
             <a:avLst>
@@ -7349,7 +7349,7 @@
         <p:spPr>
           <a:xfrm>
             <a:off x="713232" y="5120640"/>
-            <a:ext cx="4114800" cy="777240"/>
+            <a:ext cx="4937760" cy="777240"/>
           </a:xfrm>
           <a:prstGeom prst="rect">
             <a:avLst/>
@@ -7390,13 +7390,13 @@
               </a:spcAft>
             </a:pPr>
             <a:r>
-              <a:rPr sz="1900" b="1">
+              <a:rPr sz="1500" b="1">
                 <a:solidFill>
                   <a:srgbClr val="062B27"/>
                 </a:solidFill>
                 <a:latin typeface="Consolas"/>
               </a:rPr>
-              <a:t>resistanceai.streamlit.app</a:t>
+              <a:t>theresistanceaiproject.streamlit.app</a:t>
             </a:r>
           </a:p>
         </p:txBody>
@@ -10680,14 +10680,14 @@
               </a:spcAft>
             </a:pPr>
             <a:r>
-              <a:rPr sz="1600" b="0" u="sng">
+              <a:rPr sz="1300" b="0" u="sng">
                 <a:solidFill>
                   <a:srgbClr val="2DD4BF"/>
                 </a:solidFill>
                 <a:latin typeface="Consolas"/>
                 <a:hlinkClick r:id="rId3"/>
               </a:rPr>
-              <a:t>resistanceai.streamlit.app</a:t>
+              <a:t>theresistanceaiproject.streamlit.app</a:t>
             </a:r>
           </a:p>
         </p:txBody>

</xml_diff>